<commit_message>
data added to hw6
</commit_message>
<xml_diff>
--- a/hw5/MIMIC-III ML Pipeline.pptx
+++ b/hw5/MIMIC-III ML Pipeline.pptx
@@ -16,9 +16,10 @@
     <p:sldId id="263" r:id="rId10"/>
     <p:sldId id="264" r:id="rId11"/>
     <p:sldId id="265" r:id="rId12"/>
-    <p:sldId id="266" r:id="rId13"/>
-    <p:sldId id="267" r:id="rId14"/>
-    <p:sldId id="268" r:id="rId15"/>
+    <p:sldId id="271" r:id="rId13"/>
+    <p:sldId id="266" r:id="rId14"/>
+    <p:sldId id="267" r:id="rId15"/>
+    <p:sldId id="268" r:id="rId16"/>
   </p:sldIdLst>
   <p:sldSz cx="12192000" cy="6858000"/>
   <p:notesSz cx="6858000" cy="9144000"/>
@@ -139,7 +140,7 @@
 <file path=ppt/revisionInfo.xml><?xml version="1.0" encoding="utf-8"?>
 <p1510:revInfo xmlns:a="http://schemas.openxmlformats.org/drawingml/2006/main" xmlns:r="http://schemas.openxmlformats.org/officeDocument/2006/relationships" xmlns:p1510="http://schemas.microsoft.com/office/powerpoint/2015/10/main">
   <p1510:revLst>
-    <p1510:client id="{EC8A32F1-D250-41AD-9868-6AC213B7944B}" v="3" dt="2026-07-21T01:02:36.758"/>
+    <p1510:client id="{EC8A32F1-D250-41AD-9868-6AC213B7944B}" v="12" dt="2026-07-21T01:28:15.008"/>
   </p1510:revLst>
 </p1510:revInfo>
 </file>
@@ -148,11 +149,335 @@
 <pc:chgInfo xmlns:a="http://schemas.openxmlformats.org/drawingml/2006/main" xmlns:r="http://schemas.openxmlformats.org/officeDocument/2006/relationships" xmlns:ac="http://schemas.microsoft.com/office/drawing/2013/main/command" xmlns:pc="http://schemas.microsoft.com/office/powerpoint/2013/main/command">
   <pc:docChgLst>
     <pc:chgData name="Vizcaya, Luis" userId="941d56fa-29e3-4736-bcb4-21f7e43fa728" providerId="ADAL" clId="{C653503E-0A25-43B8-BF88-B9F22AE83660}"/>
-    <pc:docChg chg="custSel delSld modSld">
-      <pc:chgData name="Vizcaya, Luis" userId="941d56fa-29e3-4736-bcb4-21f7e43fa728" providerId="ADAL" clId="{C653503E-0A25-43B8-BF88-B9F22AE83660}" dt="2026-07-21T01:03:56.227" v="32" actId="47"/>
+    <pc:docChg chg="undo custSel addSld delSld modSld">
+      <pc:chgData name="Vizcaya, Luis" userId="941d56fa-29e3-4736-bcb4-21f7e43fa728" providerId="ADAL" clId="{C653503E-0A25-43B8-BF88-B9F22AE83660}" dt="2026-07-21T01:38:34.560" v="1379" actId="1076"/>
       <pc:docMkLst>
         <pc:docMk/>
       </pc:docMkLst>
+      <pc:sldChg chg="addSp delSp modSp mod">
+        <pc:chgData name="Vizcaya, Luis" userId="941d56fa-29e3-4736-bcb4-21f7e43fa728" providerId="ADAL" clId="{C653503E-0A25-43B8-BF88-B9F22AE83660}" dt="2026-07-21T01:38:34.560" v="1379" actId="1076"/>
+        <pc:sldMkLst>
+          <pc:docMk/>
+          <pc:sldMk cId="0" sldId="260"/>
+        </pc:sldMkLst>
+        <pc:spChg chg="del">
+          <ac:chgData name="Vizcaya, Luis" userId="941d56fa-29e3-4736-bcb4-21f7e43fa728" providerId="ADAL" clId="{C653503E-0A25-43B8-BF88-B9F22AE83660}" dt="2026-07-21T01:05:31.743" v="36" actId="478"/>
+          <ac:spMkLst>
+            <pc:docMk/>
+            <pc:sldMk cId="0" sldId="260"/>
+            <ac:spMk id="6" creationId="{00000000-0000-0000-0000-000000000000}"/>
+          </ac:spMkLst>
+        </pc:spChg>
+        <pc:spChg chg="mod">
+          <ac:chgData name="Vizcaya, Luis" userId="941d56fa-29e3-4736-bcb4-21f7e43fa728" providerId="ADAL" clId="{C653503E-0A25-43B8-BF88-B9F22AE83660}" dt="2026-07-21T01:38:02.241" v="1374" actId="14100"/>
+          <ac:spMkLst>
+            <pc:docMk/>
+            <pc:sldMk cId="0" sldId="260"/>
+            <ac:spMk id="7" creationId="{00000000-0000-0000-0000-000000000000}"/>
+          </ac:spMkLst>
+        </pc:spChg>
+        <pc:spChg chg="add del">
+          <ac:chgData name="Vizcaya, Luis" userId="941d56fa-29e3-4736-bcb4-21f7e43fa728" providerId="ADAL" clId="{C653503E-0A25-43B8-BF88-B9F22AE83660}" dt="2026-07-21T01:06:10.959" v="79" actId="478"/>
+          <ac:spMkLst>
+            <pc:docMk/>
+            <pc:sldMk cId="0" sldId="260"/>
+            <ac:spMk id="8" creationId="{00000000-0000-0000-0000-000000000000}"/>
+          </ac:spMkLst>
+        </pc:spChg>
+        <pc:spChg chg="del mod">
+          <ac:chgData name="Vizcaya, Luis" userId="941d56fa-29e3-4736-bcb4-21f7e43fa728" providerId="ADAL" clId="{C653503E-0A25-43B8-BF88-B9F22AE83660}" dt="2026-07-21T01:07:25.235" v="135"/>
+          <ac:spMkLst>
+            <pc:docMk/>
+            <pc:sldMk cId="0" sldId="260"/>
+            <ac:spMk id="9" creationId="{00000000-0000-0000-0000-000000000000}"/>
+          </ac:spMkLst>
+        </pc:spChg>
+        <pc:spChg chg="del mod">
+          <ac:chgData name="Vizcaya, Luis" userId="941d56fa-29e3-4736-bcb4-21f7e43fa728" providerId="ADAL" clId="{C653503E-0A25-43B8-BF88-B9F22AE83660}" dt="2026-07-21T01:07:25.235" v="133"/>
+          <ac:spMkLst>
+            <pc:docMk/>
+            <pc:sldMk cId="0" sldId="260"/>
+            <ac:spMk id="10" creationId="{00000000-0000-0000-0000-000000000000}"/>
+          </ac:spMkLst>
+        </pc:spChg>
+        <pc:spChg chg="del mod">
+          <ac:chgData name="Vizcaya, Luis" userId="941d56fa-29e3-4736-bcb4-21f7e43fa728" providerId="ADAL" clId="{C653503E-0A25-43B8-BF88-B9F22AE83660}" dt="2026-07-21T01:07:25.235" v="137"/>
+          <ac:spMkLst>
+            <pc:docMk/>
+            <pc:sldMk cId="0" sldId="260"/>
+            <ac:spMk id="11" creationId="{00000000-0000-0000-0000-000000000000}"/>
+          </ac:spMkLst>
+        </pc:spChg>
+        <pc:picChg chg="del">
+          <ac:chgData name="Vizcaya, Luis" userId="941d56fa-29e3-4736-bcb4-21f7e43fa728" providerId="ADAL" clId="{C653503E-0A25-43B8-BF88-B9F22AE83660}" dt="2026-07-21T01:07:25.235" v="131" actId="478"/>
+          <ac:picMkLst>
+            <pc:docMk/>
+            <pc:sldMk cId="0" sldId="260"/>
+            <ac:picMk id="3" creationId="{00000000-0000-0000-0000-000000000000}"/>
+          </ac:picMkLst>
+        </pc:picChg>
+        <pc:picChg chg="del">
+          <ac:chgData name="Vizcaya, Luis" userId="941d56fa-29e3-4736-bcb4-21f7e43fa728" providerId="ADAL" clId="{C653503E-0A25-43B8-BF88-B9F22AE83660}" dt="2026-07-21T01:07:26.161" v="138" actId="478"/>
+          <ac:picMkLst>
+            <pc:docMk/>
+            <pc:sldMk cId="0" sldId="260"/>
+            <ac:picMk id="4" creationId="{00000000-0000-0000-0000-000000000000}"/>
+          </ac:picMkLst>
+        </pc:picChg>
+        <pc:picChg chg="del">
+          <ac:chgData name="Vizcaya, Luis" userId="941d56fa-29e3-4736-bcb4-21f7e43fa728" providerId="ADAL" clId="{C653503E-0A25-43B8-BF88-B9F22AE83660}" dt="2026-07-21T01:07:26.773" v="139" actId="478"/>
+          <ac:picMkLst>
+            <pc:docMk/>
+            <pc:sldMk cId="0" sldId="260"/>
+            <ac:picMk id="5" creationId="{00000000-0000-0000-0000-000000000000}"/>
+          </ac:picMkLst>
+        </pc:picChg>
+        <pc:picChg chg="del">
+          <ac:chgData name="Vizcaya, Luis" userId="941d56fa-29e3-4736-bcb4-21f7e43fa728" providerId="ADAL" clId="{C653503E-0A25-43B8-BF88-B9F22AE83660}" dt="2026-07-21T01:05:18.796" v="33" actId="478"/>
+          <ac:picMkLst>
+            <pc:docMk/>
+            <pc:sldMk cId="0" sldId="260"/>
+            <ac:picMk id="12" creationId="{00000000-0000-0000-0000-000000000000}"/>
+          </ac:picMkLst>
+        </pc:picChg>
+        <pc:picChg chg="del">
+          <ac:chgData name="Vizcaya, Luis" userId="941d56fa-29e3-4736-bcb4-21f7e43fa728" providerId="ADAL" clId="{C653503E-0A25-43B8-BF88-B9F22AE83660}" dt="2026-07-21T01:05:19.965" v="34" actId="478"/>
+          <ac:picMkLst>
+            <pc:docMk/>
+            <pc:sldMk cId="0" sldId="260"/>
+            <ac:picMk id="13" creationId="{00000000-0000-0000-0000-000000000000}"/>
+          </ac:picMkLst>
+        </pc:picChg>
+        <pc:picChg chg="del">
+          <ac:chgData name="Vizcaya, Luis" userId="941d56fa-29e3-4736-bcb4-21f7e43fa728" providerId="ADAL" clId="{C653503E-0A25-43B8-BF88-B9F22AE83660}" dt="2026-07-21T01:05:21.132" v="35" actId="478"/>
+          <ac:picMkLst>
+            <pc:docMk/>
+            <pc:sldMk cId="0" sldId="260"/>
+            <ac:picMk id="14" creationId="{00000000-0000-0000-0000-000000000000}"/>
+          </ac:picMkLst>
+        </pc:picChg>
+        <pc:picChg chg="add del mod">
+          <ac:chgData name="Vizcaya, Luis" userId="941d56fa-29e3-4736-bcb4-21f7e43fa728" providerId="ADAL" clId="{C653503E-0A25-43B8-BF88-B9F22AE83660}" dt="2026-07-21T01:38:34.560" v="1379" actId="1076"/>
+          <ac:picMkLst>
+            <pc:docMk/>
+            <pc:sldMk cId="0" sldId="260"/>
+            <ac:picMk id="18" creationId="{BCE55053-F517-4676-F80C-D4977BCFA1FB}"/>
+          </ac:picMkLst>
+        </pc:picChg>
+      </pc:sldChg>
+      <pc:sldChg chg="addSp delSp modSp mod">
+        <pc:chgData name="Vizcaya, Luis" userId="941d56fa-29e3-4736-bcb4-21f7e43fa728" providerId="ADAL" clId="{C653503E-0A25-43B8-BF88-B9F22AE83660}" dt="2026-07-21T01:37:55.435" v="1370" actId="14100"/>
+        <pc:sldMkLst>
+          <pc:docMk/>
+          <pc:sldMk cId="0" sldId="261"/>
+        </pc:sldMkLst>
+        <pc:spChg chg="del">
+          <ac:chgData name="Vizcaya, Luis" userId="941d56fa-29e3-4736-bcb4-21f7e43fa728" providerId="ADAL" clId="{C653503E-0A25-43B8-BF88-B9F22AE83660}" dt="2026-07-21T01:08:33.093" v="180" actId="478"/>
+          <ac:spMkLst>
+            <pc:docMk/>
+            <pc:sldMk cId="0" sldId="261"/>
+            <ac:spMk id="5" creationId="{00000000-0000-0000-0000-000000000000}"/>
+          </ac:spMkLst>
+        </pc:spChg>
+        <pc:spChg chg="mod">
+          <ac:chgData name="Vizcaya, Luis" userId="941d56fa-29e3-4736-bcb4-21f7e43fa728" providerId="ADAL" clId="{C653503E-0A25-43B8-BF88-B9F22AE83660}" dt="2026-07-21T01:37:55.435" v="1370" actId="14100"/>
+          <ac:spMkLst>
+            <pc:docMk/>
+            <pc:sldMk cId="0" sldId="261"/>
+            <ac:spMk id="6" creationId="{00000000-0000-0000-0000-000000000000}"/>
+          </ac:spMkLst>
+        </pc:spChg>
+        <pc:spChg chg="del">
+          <ac:chgData name="Vizcaya, Luis" userId="941d56fa-29e3-4736-bcb4-21f7e43fa728" providerId="ADAL" clId="{C653503E-0A25-43B8-BF88-B9F22AE83660}" dt="2026-07-21T01:08:49.076" v="207" actId="478"/>
+          <ac:spMkLst>
+            <pc:docMk/>
+            <pc:sldMk cId="0" sldId="261"/>
+            <ac:spMk id="7" creationId="{00000000-0000-0000-0000-000000000000}"/>
+          </ac:spMkLst>
+        </pc:spChg>
+        <pc:spChg chg="del mod">
+          <ac:chgData name="Vizcaya, Luis" userId="941d56fa-29e3-4736-bcb4-21f7e43fa728" providerId="ADAL" clId="{C653503E-0A25-43B8-BF88-B9F22AE83660}" dt="2026-07-21T01:09:07.589" v="216"/>
+          <ac:spMkLst>
+            <pc:docMk/>
+            <pc:sldMk cId="0" sldId="261"/>
+            <ac:spMk id="8" creationId="{00000000-0000-0000-0000-000000000000}"/>
+          </ac:spMkLst>
+        </pc:spChg>
+        <pc:picChg chg="del">
+          <ac:chgData name="Vizcaya, Luis" userId="941d56fa-29e3-4736-bcb4-21f7e43fa728" providerId="ADAL" clId="{C653503E-0A25-43B8-BF88-B9F22AE83660}" dt="2026-07-21T01:08:50.305" v="208" actId="478"/>
+          <ac:picMkLst>
+            <pc:docMk/>
+            <pc:sldMk cId="0" sldId="261"/>
+            <ac:picMk id="2" creationId="{00000000-0000-0000-0000-000000000000}"/>
+          </ac:picMkLst>
+        </pc:picChg>
+        <pc:picChg chg="del">
+          <ac:chgData name="Vizcaya, Luis" userId="941d56fa-29e3-4736-bcb4-21f7e43fa728" providerId="ADAL" clId="{C653503E-0A25-43B8-BF88-B9F22AE83660}" dt="2026-07-21T01:08:35.233" v="181" actId="478"/>
+          <ac:picMkLst>
+            <pc:docMk/>
+            <pc:sldMk cId="0" sldId="261"/>
+            <ac:picMk id="3" creationId="{00000000-0000-0000-0000-000000000000}"/>
+          </ac:picMkLst>
+        </pc:picChg>
+        <pc:picChg chg="del">
+          <ac:chgData name="Vizcaya, Luis" userId="941d56fa-29e3-4736-bcb4-21f7e43fa728" providerId="ADAL" clId="{C653503E-0A25-43B8-BF88-B9F22AE83660}" dt="2026-07-21T01:08:51.029" v="209" actId="478"/>
+          <ac:picMkLst>
+            <pc:docMk/>
+            <pc:sldMk cId="0" sldId="261"/>
+            <ac:picMk id="4" creationId="{00000000-0000-0000-0000-000000000000}"/>
+          </ac:picMkLst>
+        </pc:picChg>
+        <pc:picChg chg="add mod">
+          <ac:chgData name="Vizcaya, Luis" userId="941d56fa-29e3-4736-bcb4-21f7e43fa728" providerId="ADAL" clId="{C653503E-0A25-43B8-BF88-B9F22AE83660}" dt="2026-07-21T01:34:47.626" v="1305" actId="1076"/>
+          <ac:picMkLst>
+            <pc:docMk/>
+            <pc:sldMk cId="0" sldId="261"/>
+            <ac:picMk id="12" creationId="{B13E4AA7-F69B-893A-06B2-E9777935812A}"/>
+          </ac:picMkLst>
+        </pc:picChg>
+      </pc:sldChg>
+      <pc:sldChg chg="addSp delSp modSp mod">
+        <pc:chgData name="Vizcaya, Luis" userId="941d56fa-29e3-4736-bcb4-21f7e43fa728" providerId="ADAL" clId="{C653503E-0A25-43B8-BF88-B9F22AE83660}" dt="2026-07-21T01:15:07.999" v="240" actId="1076"/>
+        <pc:sldMkLst>
+          <pc:docMk/>
+          <pc:sldMk cId="0" sldId="264"/>
+        </pc:sldMkLst>
+        <pc:spChg chg="del">
+          <ac:chgData name="Vizcaya, Luis" userId="941d56fa-29e3-4736-bcb4-21f7e43fa728" providerId="ADAL" clId="{C653503E-0A25-43B8-BF88-B9F22AE83660}" dt="2026-07-21T01:14:16.620" v="233" actId="478"/>
+          <ac:spMkLst>
+            <pc:docMk/>
+            <pc:sldMk cId="0" sldId="264"/>
+            <ac:spMk id="6" creationId="{00000000-0000-0000-0000-000000000000}"/>
+          </ac:spMkLst>
+        </pc:spChg>
+        <pc:spChg chg="add del">
+          <ac:chgData name="Vizcaya, Luis" userId="941d56fa-29e3-4736-bcb4-21f7e43fa728" providerId="ADAL" clId="{C653503E-0A25-43B8-BF88-B9F22AE83660}" dt="2026-07-21T01:14:54.624" v="236" actId="478"/>
+          <ac:spMkLst>
+            <pc:docMk/>
+            <pc:sldMk cId="0" sldId="264"/>
+            <ac:spMk id="7" creationId="{0344D49A-5105-7221-D425-4E4F0DB7027F}"/>
+          </ac:spMkLst>
+        </pc:spChg>
+        <pc:spChg chg="del">
+          <ac:chgData name="Vizcaya, Luis" userId="941d56fa-29e3-4736-bcb4-21f7e43fa728" providerId="ADAL" clId="{C653503E-0A25-43B8-BF88-B9F22AE83660}" dt="2026-07-21T01:14:16.620" v="233" actId="478"/>
+          <ac:spMkLst>
+            <pc:docMk/>
+            <pc:sldMk cId="0" sldId="264"/>
+            <ac:spMk id="8" creationId="{00000000-0000-0000-0000-000000000000}"/>
+          </ac:spMkLst>
+        </pc:spChg>
+        <pc:spChg chg="add del mod">
+          <ac:chgData name="Vizcaya, Luis" userId="941d56fa-29e3-4736-bcb4-21f7e43fa728" providerId="ADAL" clId="{C653503E-0A25-43B8-BF88-B9F22AE83660}" dt="2026-07-21T01:14:54.624" v="236" actId="478"/>
+          <ac:spMkLst>
+            <pc:docMk/>
+            <pc:sldMk cId="0" sldId="264"/>
+            <ac:spMk id="9" creationId="{FB727394-E256-F97A-2F04-0E609528E48C}"/>
+          </ac:spMkLst>
+        </pc:spChg>
+        <pc:spChg chg="del">
+          <ac:chgData name="Vizcaya, Luis" userId="941d56fa-29e3-4736-bcb4-21f7e43fa728" providerId="ADAL" clId="{C653503E-0A25-43B8-BF88-B9F22AE83660}" dt="2026-07-21T01:14:16.620" v="233" actId="478"/>
+          <ac:spMkLst>
+            <pc:docMk/>
+            <pc:sldMk cId="0" sldId="264"/>
+            <ac:spMk id="10" creationId="{00000000-0000-0000-0000-000000000000}"/>
+          </ac:spMkLst>
+        </pc:spChg>
+        <pc:spChg chg="mod">
+          <ac:chgData name="Vizcaya, Luis" userId="941d56fa-29e3-4736-bcb4-21f7e43fa728" providerId="ADAL" clId="{C653503E-0A25-43B8-BF88-B9F22AE83660}" dt="2026-07-21T01:09:27.398" v="230" actId="20577"/>
+          <ac:spMkLst>
+            <pc:docMk/>
+            <pc:sldMk cId="0" sldId="264"/>
+            <ac:spMk id="15" creationId="{00000000-0000-0000-0000-000000000000}"/>
+          </ac:spMkLst>
+        </pc:spChg>
+        <pc:picChg chg="del mod">
+          <ac:chgData name="Vizcaya, Luis" userId="941d56fa-29e3-4736-bcb4-21f7e43fa728" providerId="ADAL" clId="{C653503E-0A25-43B8-BF88-B9F22AE83660}" dt="2026-07-21T01:14:09.931" v="232" actId="478"/>
+          <ac:picMkLst>
+            <pc:docMk/>
+            <pc:sldMk cId="0" sldId="264"/>
+            <ac:picMk id="2" creationId="{00000000-0000-0000-0000-000000000000}"/>
+          </ac:picMkLst>
+        </pc:picChg>
+        <pc:picChg chg="del">
+          <ac:chgData name="Vizcaya, Luis" userId="941d56fa-29e3-4736-bcb4-21f7e43fa728" providerId="ADAL" clId="{C653503E-0A25-43B8-BF88-B9F22AE83660}" dt="2026-07-21T01:14:16.620" v="233" actId="478"/>
+          <ac:picMkLst>
+            <pc:docMk/>
+            <pc:sldMk cId="0" sldId="264"/>
+            <ac:picMk id="3" creationId="{00000000-0000-0000-0000-000000000000}"/>
+          </ac:picMkLst>
+        </pc:picChg>
+        <pc:picChg chg="del">
+          <ac:chgData name="Vizcaya, Luis" userId="941d56fa-29e3-4736-bcb4-21f7e43fa728" providerId="ADAL" clId="{C653503E-0A25-43B8-BF88-B9F22AE83660}" dt="2026-07-21T01:14:16.620" v="233" actId="478"/>
+          <ac:picMkLst>
+            <pc:docMk/>
+            <pc:sldMk cId="0" sldId="264"/>
+            <ac:picMk id="4" creationId="{00000000-0000-0000-0000-000000000000}"/>
+          </ac:picMkLst>
+        </pc:picChg>
+        <pc:picChg chg="del">
+          <ac:chgData name="Vizcaya, Luis" userId="941d56fa-29e3-4736-bcb4-21f7e43fa728" providerId="ADAL" clId="{C653503E-0A25-43B8-BF88-B9F22AE83660}" dt="2026-07-21T01:14:16.620" v="233" actId="478"/>
+          <ac:picMkLst>
+            <pc:docMk/>
+            <pc:sldMk cId="0" sldId="264"/>
+            <ac:picMk id="5" creationId="{00000000-0000-0000-0000-000000000000}"/>
+          </ac:picMkLst>
+        </pc:picChg>
+        <pc:picChg chg="del">
+          <ac:chgData name="Vizcaya, Luis" userId="941d56fa-29e3-4736-bcb4-21f7e43fa728" providerId="ADAL" clId="{C653503E-0A25-43B8-BF88-B9F22AE83660}" dt="2026-07-21T01:14:16.620" v="233" actId="478"/>
+          <ac:picMkLst>
+            <pc:docMk/>
+            <pc:sldMk cId="0" sldId="264"/>
+            <ac:picMk id="12" creationId="{00000000-0000-0000-0000-000000000000}"/>
+          </ac:picMkLst>
+        </pc:picChg>
+        <pc:picChg chg="del">
+          <ac:chgData name="Vizcaya, Luis" userId="941d56fa-29e3-4736-bcb4-21f7e43fa728" providerId="ADAL" clId="{C653503E-0A25-43B8-BF88-B9F22AE83660}" dt="2026-07-21T01:14:16.620" v="233" actId="478"/>
+          <ac:picMkLst>
+            <pc:docMk/>
+            <pc:sldMk cId="0" sldId="264"/>
+            <ac:picMk id="13" creationId="{00000000-0000-0000-0000-000000000000}"/>
+          </ac:picMkLst>
+        </pc:picChg>
+        <pc:picChg chg="del">
+          <ac:chgData name="Vizcaya, Luis" userId="941d56fa-29e3-4736-bcb4-21f7e43fa728" providerId="ADAL" clId="{C653503E-0A25-43B8-BF88-B9F22AE83660}" dt="2026-07-21T01:14:16.620" v="233" actId="478"/>
+          <ac:picMkLst>
+            <pc:docMk/>
+            <pc:sldMk cId="0" sldId="264"/>
+            <ac:picMk id="14" creationId="{00000000-0000-0000-0000-000000000000}"/>
+          </ac:picMkLst>
+        </pc:picChg>
+        <pc:picChg chg="add mod">
+          <ac:chgData name="Vizcaya, Luis" userId="941d56fa-29e3-4736-bcb4-21f7e43fa728" providerId="ADAL" clId="{C653503E-0A25-43B8-BF88-B9F22AE83660}" dt="2026-07-21T01:15:07.999" v="240" actId="1076"/>
+          <ac:picMkLst>
+            <pc:docMk/>
+            <pc:sldMk cId="0" sldId="264"/>
+            <ac:picMk id="17" creationId="{BE8C9274-10A5-B5DE-E720-E0E990D21C20}"/>
+          </ac:picMkLst>
+        </pc:picChg>
+      </pc:sldChg>
+      <pc:sldChg chg="addSp delSp modSp mod">
+        <pc:chgData name="Vizcaya, Luis" userId="941d56fa-29e3-4736-bcb4-21f7e43fa728" providerId="ADAL" clId="{C653503E-0A25-43B8-BF88-B9F22AE83660}" dt="2026-07-21T01:18:07.487" v="277" actId="22"/>
+        <pc:sldMkLst>
+          <pc:docMk/>
+          <pc:sldMk cId="0" sldId="265"/>
+        </pc:sldMkLst>
+        <pc:spChg chg="mod">
+          <ac:chgData name="Vizcaya, Luis" userId="941d56fa-29e3-4736-bcb4-21f7e43fa728" providerId="ADAL" clId="{C653503E-0A25-43B8-BF88-B9F22AE83660}" dt="2026-07-21T01:15:44.771" v="253" actId="113"/>
+          <ac:spMkLst>
+            <pc:docMk/>
+            <pc:sldMk cId="0" sldId="265"/>
+            <ac:spMk id="6" creationId="{00000000-0000-0000-0000-000000000000}"/>
+          </ac:spMkLst>
+        </pc:spChg>
+        <pc:picChg chg="add del">
+          <ac:chgData name="Vizcaya, Luis" userId="941d56fa-29e3-4736-bcb4-21f7e43fa728" providerId="ADAL" clId="{C653503E-0A25-43B8-BF88-B9F22AE83660}" dt="2026-07-21T01:18:07.487" v="277" actId="22"/>
+          <ac:picMkLst>
+            <pc:docMk/>
+            <pc:sldMk cId="0" sldId="265"/>
+            <ac:picMk id="11" creationId="{EC16589D-8770-6F19-4823-56E403252799}"/>
+          </ac:picMkLst>
+        </pc:picChg>
+      </pc:sldChg>
       <pc:sldChg chg="addSp delSp modSp mod">
         <pc:chgData name="Vizcaya, Luis" userId="941d56fa-29e3-4736-bcb4-21f7e43fa728" providerId="ADAL" clId="{C653503E-0A25-43B8-BF88-B9F22AE83660}" dt="2026-07-21T01:03:49.336" v="31" actId="14100"/>
         <pc:sldMkLst>
@@ -240,12 +565,130 @@
           </ac:picMkLst>
         </pc:picChg>
       </pc:sldChg>
+      <pc:sldChg chg="delSp modSp mod">
+        <pc:chgData name="Vizcaya, Luis" userId="941d56fa-29e3-4736-bcb4-21f7e43fa728" providerId="ADAL" clId="{C653503E-0A25-43B8-BF88-B9F22AE83660}" dt="2026-07-21T01:32:37.738" v="1303" actId="1076"/>
+        <pc:sldMkLst>
+          <pc:docMk/>
+          <pc:sldMk cId="0" sldId="268"/>
+        </pc:sldMkLst>
+        <pc:spChg chg="mod">
+          <ac:chgData name="Vizcaya, Luis" userId="941d56fa-29e3-4736-bcb4-21f7e43fa728" providerId="ADAL" clId="{C653503E-0A25-43B8-BF88-B9F22AE83660}" dt="2026-07-21T01:32:28.358" v="1301" actId="1076"/>
+          <ac:spMkLst>
+            <pc:docMk/>
+            <pc:sldMk cId="0" sldId="268"/>
+            <ac:spMk id="3" creationId="{00000000-0000-0000-0000-000000000000}"/>
+          </ac:spMkLst>
+        </pc:spChg>
+        <pc:spChg chg="mod">
+          <ac:chgData name="Vizcaya, Luis" userId="941d56fa-29e3-4736-bcb4-21f7e43fa728" providerId="ADAL" clId="{C653503E-0A25-43B8-BF88-B9F22AE83660}" dt="2026-07-21T01:32:37.738" v="1303" actId="1076"/>
+          <ac:spMkLst>
+            <pc:docMk/>
+            <pc:sldMk cId="0" sldId="268"/>
+            <ac:spMk id="4" creationId="{00000000-0000-0000-0000-000000000000}"/>
+          </ac:spMkLst>
+        </pc:spChg>
+        <pc:picChg chg="del mod">
+          <ac:chgData name="Vizcaya, Luis" userId="941d56fa-29e3-4736-bcb4-21f7e43fa728" providerId="ADAL" clId="{C653503E-0A25-43B8-BF88-B9F22AE83660}" dt="2026-07-21T01:19:58.586" v="412" actId="478"/>
+          <ac:picMkLst>
+            <pc:docMk/>
+            <pc:sldMk cId="0" sldId="268"/>
+            <ac:picMk id="2" creationId="{00000000-0000-0000-0000-000000000000}"/>
+          </ac:picMkLst>
+        </pc:picChg>
+      </pc:sldChg>
       <pc:sldChg chg="del">
         <pc:chgData name="Vizcaya, Luis" userId="941d56fa-29e3-4736-bcb4-21f7e43fa728" providerId="ADAL" clId="{C653503E-0A25-43B8-BF88-B9F22AE83660}" dt="2026-07-21T01:03:56.227" v="32" actId="47"/>
         <pc:sldMkLst>
           <pc:docMk/>
           <pc:sldMk cId="0" sldId="269"/>
         </pc:sldMkLst>
+      </pc:sldChg>
+      <pc:sldChg chg="addSp delSp modSp add mod">
+        <pc:chgData name="Vizcaya, Luis" userId="941d56fa-29e3-4736-bcb4-21f7e43fa728" providerId="ADAL" clId="{C653503E-0A25-43B8-BF88-B9F22AE83660}" dt="2026-07-21T01:32:17.524" v="1300" actId="20577"/>
+        <pc:sldMkLst>
+          <pc:docMk/>
+          <pc:sldMk cId="3775596006" sldId="271"/>
+        </pc:sldMkLst>
+        <pc:spChg chg="del">
+          <ac:chgData name="Vizcaya, Luis" userId="941d56fa-29e3-4736-bcb4-21f7e43fa728" providerId="ADAL" clId="{C653503E-0A25-43B8-BF88-B9F22AE83660}" dt="2026-07-21T01:18:41.365" v="328" actId="478"/>
+          <ac:spMkLst>
+            <pc:docMk/>
+            <pc:sldMk cId="3775596006" sldId="271"/>
+            <ac:spMk id="3" creationId="{DAE50A37-4366-5EBA-9E6C-1AAEADADACF7}"/>
+          </ac:spMkLst>
+        </pc:spChg>
+        <pc:spChg chg="del">
+          <ac:chgData name="Vizcaya, Luis" userId="941d56fa-29e3-4736-bcb4-21f7e43fa728" providerId="ADAL" clId="{C653503E-0A25-43B8-BF88-B9F22AE83660}" dt="2026-07-21T01:18:48.142" v="329" actId="478"/>
+          <ac:spMkLst>
+            <pc:docMk/>
+            <pc:sldMk cId="3775596006" sldId="271"/>
+            <ac:spMk id="4" creationId="{2DD617FB-FAE5-46FF-60B7-F2C1C6D07D9F}"/>
+          </ac:spMkLst>
+        </pc:spChg>
+        <pc:spChg chg="del">
+          <ac:chgData name="Vizcaya, Luis" userId="941d56fa-29e3-4736-bcb4-21f7e43fa728" providerId="ADAL" clId="{C653503E-0A25-43B8-BF88-B9F22AE83660}" dt="2026-07-21T01:18:54.311" v="330" actId="478"/>
+          <ac:spMkLst>
+            <pc:docMk/>
+            <pc:sldMk cId="3775596006" sldId="271"/>
+            <ac:spMk id="5" creationId="{555B41B2-1FB8-A7ED-62CC-FD7CFC000DE0}"/>
+          </ac:spMkLst>
+        </pc:spChg>
+        <pc:spChg chg="del">
+          <ac:chgData name="Vizcaya, Luis" userId="941d56fa-29e3-4736-bcb4-21f7e43fa728" providerId="ADAL" clId="{C653503E-0A25-43B8-BF88-B9F22AE83660}" dt="2026-07-21T01:18:54.311" v="330" actId="478"/>
+          <ac:spMkLst>
+            <pc:docMk/>
+            <pc:sldMk cId="3775596006" sldId="271"/>
+            <ac:spMk id="6" creationId="{3AE2224E-2531-2441-D1D8-8117A82A15DB}"/>
+          </ac:spMkLst>
+        </pc:spChg>
+        <pc:spChg chg="del">
+          <ac:chgData name="Vizcaya, Luis" userId="941d56fa-29e3-4736-bcb4-21f7e43fa728" providerId="ADAL" clId="{C653503E-0A25-43B8-BF88-B9F22AE83660}" dt="2026-07-21T01:18:54.311" v="330" actId="478"/>
+          <ac:spMkLst>
+            <pc:docMk/>
+            <pc:sldMk cId="3775596006" sldId="271"/>
+            <ac:spMk id="7" creationId="{49E3D61D-1723-BF42-BB47-CEF574AB4A27}"/>
+          </ac:spMkLst>
+        </pc:spChg>
+        <pc:spChg chg="mod">
+          <ac:chgData name="Vizcaya, Luis" userId="941d56fa-29e3-4736-bcb4-21f7e43fa728" providerId="ADAL" clId="{C653503E-0A25-43B8-BF88-B9F22AE83660}" dt="2026-07-21T01:18:30.741" v="325" actId="6549"/>
+          <ac:spMkLst>
+            <pc:docMk/>
+            <pc:sldMk cId="3775596006" sldId="271"/>
+            <ac:spMk id="8" creationId="{6B145DE3-B967-486D-8F8D-CEB735820FB9}"/>
+          </ac:spMkLst>
+        </pc:spChg>
+        <pc:spChg chg="add mod">
+          <ac:chgData name="Vizcaya, Luis" userId="941d56fa-29e3-4736-bcb4-21f7e43fa728" providerId="ADAL" clId="{C653503E-0A25-43B8-BF88-B9F22AE83660}" dt="2026-07-21T01:32:17.524" v="1300" actId="20577"/>
+          <ac:spMkLst>
+            <pc:docMk/>
+            <pc:sldMk cId="3775596006" sldId="271"/>
+            <ac:spMk id="14" creationId="{F1F81FCC-278E-ABD4-3F48-A30E454BB3F6}"/>
+          </ac:spMkLst>
+        </pc:spChg>
+        <pc:picChg chg="del mod">
+          <ac:chgData name="Vizcaya, Luis" userId="941d56fa-29e3-4736-bcb4-21f7e43fa728" providerId="ADAL" clId="{C653503E-0A25-43B8-BF88-B9F22AE83660}" dt="2026-07-21T01:18:34.793" v="327" actId="478"/>
+          <ac:picMkLst>
+            <pc:docMk/>
+            <pc:sldMk cId="3775596006" sldId="271"/>
+            <ac:picMk id="2" creationId="{075A80FE-A8E1-31C0-C33E-D9C94EB4C645}"/>
+          </ac:picMkLst>
+        </pc:picChg>
+        <pc:picChg chg="add del mod">
+          <ac:chgData name="Vizcaya, Luis" userId="941d56fa-29e3-4736-bcb4-21f7e43fa728" providerId="ADAL" clId="{C653503E-0A25-43B8-BF88-B9F22AE83660}" dt="2026-07-21T01:26:41.964" v="931" actId="478"/>
+          <ac:picMkLst>
+            <pc:docMk/>
+            <pc:sldMk cId="3775596006" sldId="271"/>
+            <ac:picMk id="11" creationId="{70845224-CEED-1E9B-1781-B2C37A89FFB5}"/>
+          </ac:picMkLst>
+        </pc:picChg>
+        <pc:picChg chg="add mod">
+          <ac:chgData name="Vizcaya, Luis" userId="941d56fa-29e3-4736-bcb4-21f7e43fa728" providerId="ADAL" clId="{C653503E-0A25-43B8-BF88-B9F22AE83660}" dt="2026-07-21T01:26:47.613" v="934" actId="14100"/>
+          <ac:picMkLst>
+            <pc:docMk/>
+            <pc:sldMk cId="3775596006" sldId="271"/>
+            <ac:picMk id="13" creationId="{CCD79E42-0582-4A24-1E72-7768CC7CEE14}"/>
+          </ac:picMkLst>
+        </pc:picChg>
       </pc:sldChg>
     </pc:docChg>
   </pc:docChgLst>
@@ -3398,112 +3841,16 @@
           <a:chExt cx="0" cy="0"/>
         </a:xfrm>
       </p:grpSpPr>
-      <p:pic>
-        <p:nvPicPr>
-          <p:cNvPr id="2" name="Picture 1" descr="image.png"/>
-          <p:cNvPicPr>
-            <a:picLocks noChangeAspect="1"/>
-          </p:cNvPicPr>
-          <p:nvPr/>
-        </p:nvPicPr>
-        <p:blipFill>
-          <a:blip r:embed="rId2"/>
-          <a:stretch>
-            <a:fillRect/>
-          </a:stretch>
-        </p:blipFill>
-        <p:spPr>
-          <a:xfrm>
-            <a:off x="0" y="0"/>
-            <a:ext cx="12192000" cy="6858000"/>
-          </a:xfrm>
-          <a:prstGeom prst="rect">
-            <a:avLst/>
-          </a:prstGeom>
-        </p:spPr>
-      </p:pic>
-      <p:pic>
-        <p:nvPicPr>
-          <p:cNvPr id="3" name="Picture 2" descr="image.png"/>
-          <p:cNvPicPr>
-            <a:picLocks noChangeAspect="1"/>
-          </p:cNvPicPr>
-          <p:nvPr/>
-        </p:nvPicPr>
-        <p:blipFill>
-          <a:blip r:embed="rId3"/>
-          <a:stretch>
-            <a:fillRect/>
-          </a:stretch>
-        </p:blipFill>
-        <p:spPr>
-          <a:xfrm>
-            <a:off x="571500" y="1862137"/>
-            <a:ext cx="3429000" cy="2143125"/>
-          </a:xfrm>
-          <a:prstGeom prst="rect">
-            <a:avLst/>
-          </a:prstGeom>
-        </p:spPr>
-      </p:pic>
-      <p:pic>
-        <p:nvPicPr>
-          <p:cNvPr id="4" name="Picture 3" descr="image.png"/>
-          <p:cNvPicPr>
-            <a:picLocks noChangeAspect="1"/>
-          </p:cNvPicPr>
-          <p:nvPr/>
-        </p:nvPicPr>
-        <p:blipFill>
-          <a:blip r:embed="rId4"/>
-          <a:stretch>
-            <a:fillRect/>
-          </a:stretch>
-        </p:blipFill>
-        <p:spPr>
-          <a:xfrm>
-            <a:off x="4381500" y="1862137"/>
-            <a:ext cx="3429000" cy="2143125"/>
-          </a:xfrm>
-          <a:prstGeom prst="rect">
-            <a:avLst/>
-          </a:prstGeom>
-        </p:spPr>
-      </p:pic>
-      <p:pic>
-        <p:nvPicPr>
-          <p:cNvPr id="5" name="Picture 4" descr="image.png"/>
-          <p:cNvPicPr>
-            <a:picLocks noChangeAspect="1"/>
-          </p:cNvPicPr>
-          <p:nvPr/>
-        </p:nvPicPr>
-        <p:blipFill>
-          <a:blip r:embed="rId4"/>
-          <a:stretch>
-            <a:fillRect/>
-          </a:stretch>
-        </p:blipFill>
-        <p:spPr>
-          <a:xfrm>
-            <a:off x="8191500" y="1862137"/>
-            <a:ext cx="3429000" cy="2143125"/>
-          </a:xfrm>
-          <a:prstGeom prst="rect">
-            <a:avLst/>
-          </a:prstGeom>
-        </p:spPr>
-      </p:pic>
-      <p:sp>
-        <p:nvSpPr>
-          <p:cNvPr id="6" name="TextBox 5"/>
+      <p:sp>
+        <p:nvSpPr>
+          <p:cNvPr id="15" name="TextBox 14"/>
           <p:cNvSpPr txBox="1"/>
           <p:nvPr/>
         </p:nvSpPr>
         <p:spPr>
           <a:xfrm>
-            <a:off x="485775" y="4195762"/>
-            <a:ext cx="3600450" cy="323850"/>
+            <a:off x="571500" y="571500"/>
+            <a:ext cx="11601450" cy="461665"/>
           </a:xfrm>
           <a:prstGeom prst="rect">
             <a:avLst/>
@@ -3516,193 +3863,31 @@
           </a:bodyPr>
           <a:lstStyle/>
           <a:p>
-            <a:pPr algn="ctr"/>
-            <a:r>
-              <a:rPr sz="2100" b="0" i="0" u="none">
-                <a:solidFill>
-                  <a:srgbClr val="0284C7"/>
-                </a:solidFill>
-                <a:latin typeface="Montserrat SemiBold"/>
-              </a:rPr>
-              <a:t>Logistic Regression</a:t>
-            </a:r>
-          </a:p>
-        </p:txBody>
-      </p:sp>
-      <p:sp>
-        <p:nvSpPr>
-          <p:cNvPr id="8" name="TextBox 7"/>
-          <p:cNvSpPr txBox="1"/>
-          <p:nvPr/>
-        </p:nvSpPr>
-        <p:spPr>
-          <a:xfrm>
-            <a:off x="4295775" y="4195762"/>
-            <a:ext cx="3600450" cy="323850"/>
-          </a:xfrm>
-          <a:prstGeom prst="rect">
-            <a:avLst/>
-          </a:prstGeom>
-          <a:noFill/>
-        </p:spPr>
-        <p:txBody>
-          <a:bodyPr wrap="square" lIns="0" tIns="0" rIns="0" bIns="0" anchor="t">
-            <a:spAutoFit/>
-          </a:bodyPr>
-          <a:lstStyle/>
-          <a:p>
-            <a:pPr algn="ctr"/>
-            <a:r>
-              <a:rPr sz="2100" b="0" i="0" u="none">
-                <a:solidFill>
-                  <a:srgbClr val="0284C7"/>
-                </a:solidFill>
-                <a:latin typeface="Montserrat SemiBold"/>
-              </a:rPr>
-              <a:t>LightGBM</a:t>
-            </a:r>
-          </a:p>
-        </p:txBody>
-      </p:sp>
-      <p:sp>
-        <p:nvSpPr>
-          <p:cNvPr id="10" name="TextBox 9"/>
-          <p:cNvSpPr txBox="1"/>
-          <p:nvPr/>
-        </p:nvSpPr>
-        <p:spPr>
-          <a:xfrm>
-            <a:off x="8105775" y="4195762"/>
-            <a:ext cx="3600450" cy="323850"/>
-          </a:xfrm>
-          <a:prstGeom prst="rect">
-            <a:avLst/>
-          </a:prstGeom>
-          <a:noFill/>
-        </p:spPr>
-        <p:txBody>
-          <a:bodyPr wrap="square" lIns="0" tIns="0" rIns="0" bIns="0" anchor="t">
-            <a:spAutoFit/>
-          </a:bodyPr>
-          <a:lstStyle/>
-          <a:p>
-            <a:pPr algn="ctr"/>
-            <a:r>
-              <a:rPr sz="2100" b="0" i="0" u="none">
-                <a:solidFill>
-                  <a:srgbClr val="0284C7"/>
-                </a:solidFill>
-                <a:latin typeface="Montserrat SemiBold"/>
-              </a:rPr>
-              <a:t>Random Forest</a:t>
-            </a:r>
-          </a:p>
-        </p:txBody>
-      </p:sp>
-      <p:pic>
-        <p:nvPicPr>
-          <p:cNvPr id="12" name="Picture 11" descr="image.png"/>
-          <p:cNvPicPr>
-            <a:picLocks noChangeAspect="1"/>
-          </p:cNvPicPr>
-          <p:nvPr/>
-        </p:nvPicPr>
-        <p:blipFill>
-          <a:blip r:embed="rId5"/>
-          <a:stretch>
-            <a:fillRect/>
-          </a:stretch>
-        </p:blipFill>
-        <p:spPr>
-          <a:xfrm>
-            <a:off x="581025" y="1871662"/>
-            <a:ext cx="3409950" cy="2124075"/>
-          </a:xfrm>
-          <a:prstGeom prst="rect">
-            <a:avLst/>
-          </a:prstGeom>
-        </p:spPr>
-      </p:pic>
-      <p:pic>
-        <p:nvPicPr>
-          <p:cNvPr id="13" name="Picture 12" descr="image.png"/>
-          <p:cNvPicPr>
-            <a:picLocks noChangeAspect="1"/>
-          </p:cNvPicPr>
-          <p:nvPr/>
-        </p:nvPicPr>
-        <p:blipFill>
-          <a:blip r:embed="rId6"/>
-          <a:stretch>
-            <a:fillRect/>
-          </a:stretch>
-        </p:blipFill>
-        <p:spPr>
-          <a:xfrm>
-            <a:off x="4391025" y="1871662"/>
-            <a:ext cx="3409950" cy="2124075"/>
-          </a:xfrm>
-          <a:prstGeom prst="rect">
-            <a:avLst/>
-          </a:prstGeom>
-        </p:spPr>
-      </p:pic>
-      <p:pic>
-        <p:nvPicPr>
-          <p:cNvPr id="14" name="Picture 13" descr="image.png"/>
-          <p:cNvPicPr>
-            <a:picLocks noChangeAspect="1"/>
-          </p:cNvPicPr>
-          <p:nvPr/>
-        </p:nvPicPr>
-        <p:blipFill>
-          <a:blip r:embed="rId7"/>
-          <a:stretch>
-            <a:fillRect/>
-          </a:stretch>
-        </p:blipFill>
-        <p:spPr>
-          <a:xfrm>
-            <a:off x="8201025" y="1871662"/>
-            <a:ext cx="3409950" cy="2124075"/>
-          </a:xfrm>
-          <a:prstGeom prst="rect">
-            <a:avLst/>
-          </a:prstGeom>
-        </p:spPr>
-      </p:pic>
-      <p:sp>
-        <p:nvSpPr>
-          <p:cNvPr id="15" name="TextBox 14"/>
-          <p:cNvSpPr txBox="1"/>
-          <p:nvPr/>
-        </p:nvSpPr>
-        <p:spPr>
-          <a:xfrm>
-            <a:off x="571500" y="571500"/>
-            <a:ext cx="11601450" cy="504825"/>
-          </a:xfrm>
-          <a:prstGeom prst="rect">
-            <a:avLst/>
-          </a:prstGeom>
-          <a:noFill/>
-        </p:spPr>
-        <p:txBody>
-          <a:bodyPr wrap="square" lIns="0" tIns="0" rIns="0" bIns="0" anchor="t">
-            <a:spAutoFit/>
-          </a:bodyPr>
-          <a:lstStyle/>
-          <a:p>
             <a:pPr algn="l"/>
             <a:r>
-              <a:rPr sz="3000" b="1" i="0" u="none">
+              <a:rPr sz="3000" b="1" i="0" u="none" dirty="0">
                 <a:solidFill>
                   <a:srgbClr val="0F172A"/>
                 </a:solidFill>
                 <a:latin typeface="Montserrat"/>
               </a:rPr>
-              <a:t>Algorithm Selection</a:t>
-            </a:r>
+              <a:t>Algorithm </a:t>
+            </a:r>
+            <a:r>
+              <a:rPr lang="en-US" sz="3000" b="1" i="0" u="none" dirty="0">
+                <a:solidFill>
+                  <a:srgbClr val="0F172A"/>
+                </a:solidFill>
+                <a:latin typeface="Montserrat"/>
+              </a:rPr>
+              <a:t>Implementation</a:t>
+            </a:r>
+            <a:endParaRPr sz="3000" b="1" i="0" u="none" dirty="0">
+              <a:solidFill>
+                <a:srgbClr val="0F172A"/>
+              </a:solidFill>
+              <a:latin typeface="Montserrat"/>
+            </a:endParaRPr>
           </a:p>
         </p:txBody>
       </p:sp>
@@ -3751,6 +3936,36 @@
           </a:p>
         </p:txBody>
       </p:sp>
+      <p:pic>
+        <p:nvPicPr>
+          <p:cNvPr id="17" name="Picture 16">
+            <a:extLst>
+              <a:ext uri="{FF2B5EF4-FFF2-40B4-BE49-F238E27FC236}">
+                <a16:creationId xmlns:a16="http://schemas.microsoft.com/office/drawing/2014/main" id="{BE8C9274-10A5-B5DE-E720-E0E990D21C20}"/>
+              </a:ext>
+            </a:extLst>
+          </p:cNvPr>
+          <p:cNvPicPr>
+            <a:picLocks noChangeAspect="1"/>
+          </p:cNvPicPr>
+          <p:nvPr/>
+        </p:nvPicPr>
+        <p:blipFill>
+          <a:blip r:embed="rId2"/>
+          <a:stretch>
+            <a:fillRect/>
+          </a:stretch>
+        </p:blipFill>
+        <p:spPr>
+          <a:xfrm>
+            <a:off x="1095017" y="1367135"/>
+            <a:ext cx="10001965" cy="5477054"/>
+          </a:xfrm>
+          <a:prstGeom prst="rect">
+            <a:avLst/>
+          </a:prstGeom>
+        </p:spPr>
+      </p:pic>
     </p:spTree>
   </p:cSld>
   <p:clrMapOvr>
@@ -3836,7 +4051,7 @@
               </a:lnSpc>
             </a:pPr>
             <a:r>
-              <a:rPr sz="11250" b="1" i="0" u="none">
+              <a:rPr sz="11250" b="1" i="0" u="none" dirty="0">
                 <a:solidFill>
                   <a:srgbClr val="0284C7"/>
                 </a:solidFill>
@@ -3945,7 +4160,7 @@
               </a:lnSpc>
             </a:pPr>
             <a:r>
-              <a:rPr sz="1500" b="0" i="0" u="none">
+              <a:rPr sz="1500" b="0" i="0" u="none" dirty="0">
                 <a:solidFill>
                   <a:srgbClr val="334155"/>
                 </a:solidFill>
@@ -3954,22 +4169,67 @@
               <a:t>We utilized </a:t>
             </a:r>
             <a:r>
-              <a:rPr sz="1500" b="1" i="0" u="none">
+              <a:rPr lang="en-US" sz="1500" b="0" i="0" u="none" dirty="0">
                 <a:solidFill>
                   <a:srgbClr val="334155"/>
                 </a:solidFill>
                 <a:latin typeface="Open Sans"/>
               </a:rPr>
+              <a:t>the </a:t>
+            </a:r>
+            <a:r>
+              <a:rPr sz="1500" b="1" i="0" u="none" dirty="0" err="1">
+                <a:solidFill>
+                  <a:srgbClr val="334155"/>
+                </a:solidFill>
+                <a:latin typeface="Open Sans"/>
+              </a:rPr>
               <a:t>Optuna</a:t>
             </a:r>
             <a:r>
-              <a:rPr sz="1500" b="0" i="0" u="none">
+              <a:rPr sz="1500" b="0" i="0" u="none" dirty="0">
                 <a:solidFill>
                   <a:srgbClr val="334155"/>
                 </a:solidFill>
                 <a:latin typeface="Open Sans"/>
               </a:rPr>
-              <a:t> to navigate the complex hyperparameter search space automatically. By running 30 distinct trials using 5-fold cross-validation, the framework iteratively maximized our target metric: the F1-Score.</a:t>
+              <a:t> </a:t>
+            </a:r>
+            <a:r>
+              <a:rPr lang="en-US" sz="1500" b="0" i="0" u="none" dirty="0">
+                <a:solidFill>
+                  <a:srgbClr val="334155"/>
+                </a:solidFill>
+                <a:latin typeface="Open Sans"/>
+              </a:rPr>
+              <a:t>library </a:t>
+            </a:r>
+            <a:r>
+              <a:rPr sz="1500" b="0" i="0" u="none" dirty="0">
+                <a:solidFill>
+                  <a:srgbClr val="334155"/>
+                </a:solidFill>
+                <a:latin typeface="Open Sans"/>
+              </a:rPr>
+              <a:t>to navigate the complex hyperparameter search space automatically. By running 30 distinct trials using 5-fold cross-validation, the framework iteratively maximized our target metric: the </a:t>
+            </a:r>
+            <a:r>
+              <a:rPr sz="1500" b="1" i="0" u="none" dirty="0">
+                <a:solidFill>
+                  <a:srgbClr val="334155"/>
+                </a:solidFill>
+                <a:latin typeface="Open Sans"/>
+              </a:rPr>
+              <a:t>F1-Score</a:t>
+            </a:r>
+            <a:r>
+              <a:rPr sz="1500" b="0" i="0" u="none" dirty="0">
+                <a:solidFill>
+                  <a:srgbClr val="334155"/>
+                </a:solidFill>
+                <a:latin typeface="Open Sans"/>
+              </a:rPr>
+              <a:t>.</a:t>
             </a:r>
           </a:p>
         </p:txBody>
@@ -4117,6 +4377,260 @@
 </file>
 
 <file path=ppt/slides/slide12.xml><?xml version="1.0" encoding="utf-8"?>
+<p:sld xmlns:a="http://schemas.openxmlformats.org/drawingml/2006/main" xmlns:r="http://schemas.openxmlformats.org/officeDocument/2006/relationships" xmlns:p="http://schemas.openxmlformats.org/presentationml/2006/main">
+  <p:cSld>
+    <p:bg>
+      <p:bgPr>
+        <a:solidFill>
+          <a:srgbClr val="FFFFFF"/>
+        </a:solidFill>
+        <a:effectLst/>
+      </p:bgPr>
+    </p:bg>
+    <p:spTree>
+      <p:nvGrpSpPr>
+        <p:cNvPr id="1" name="">
+          <a:extLst>
+            <a:ext uri="{FF2B5EF4-FFF2-40B4-BE49-F238E27FC236}">
+              <a16:creationId xmlns:a16="http://schemas.microsoft.com/office/drawing/2014/main" id="{E10A2B3B-D3A2-5DD7-DDA9-CD24F967FE75}"/>
+            </a:ext>
+          </a:extLst>
+        </p:cNvPr>
+        <p:cNvGrpSpPr/>
+        <p:nvPr/>
+      </p:nvGrpSpPr>
+      <p:grpSpPr>
+        <a:xfrm>
+          <a:off x="0" y="0"/>
+          <a:ext cx="0" cy="0"/>
+          <a:chOff x="0" y="0"/>
+          <a:chExt cx="0" cy="0"/>
+        </a:xfrm>
+      </p:grpSpPr>
+      <p:sp>
+        <p:nvSpPr>
+          <p:cNvPr id="8" name="TextBox 7">
+            <a:extLst>
+              <a:ext uri="{FF2B5EF4-FFF2-40B4-BE49-F238E27FC236}">
+                <a16:creationId xmlns:a16="http://schemas.microsoft.com/office/drawing/2014/main" id="{6B145DE3-B967-486D-8F8D-CEB735820FB9}"/>
+              </a:ext>
+            </a:extLst>
+          </p:cNvPr>
+          <p:cNvSpPr txBox="1"/>
+          <p:nvPr/>
+        </p:nvSpPr>
+        <p:spPr>
+          <a:xfrm>
+            <a:off x="571500" y="571500"/>
+            <a:ext cx="11601450" cy="461665"/>
+          </a:xfrm>
+          <a:prstGeom prst="rect">
+            <a:avLst/>
+          </a:prstGeom>
+          <a:noFill/>
+        </p:spPr>
+        <p:txBody>
+          <a:bodyPr wrap="square" lIns="0" tIns="0" rIns="0" bIns="0" anchor="t">
+            <a:spAutoFit/>
+          </a:bodyPr>
+          <a:lstStyle/>
+          <a:p>
+            <a:pPr algn="l"/>
+            <a:r>
+              <a:rPr lang="en-US" sz="3000" b="1" i="0" u="none" dirty="0">
+                <a:solidFill>
+                  <a:srgbClr val="0F172A"/>
+                </a:solidFill>
+                <a:latin typeface="Montserrat"/>
+              </a:rPr>
+              <a:t>Confusion Matrix Comparison</a:t>
+            </a:r>
+            <a:endParaRPr sz="3000" b="1" i="0" u="none" dirty="0">
+              <a:solidFill>
+                <a:srgbClr val="0F172A"/>
+              </a:solidFill>
+              <a:latin typeface="Montserrat"/>
+            </a:endParaRPr>
+          </a:p>
+        </p:txBody>
+      </p:sp>
+      <p:sp>
+        <p:nvSpPr>
+          <p:cNvPr id="9" name="Rectangle 8">
+            <a:extLst>
+              <a:ext uri="{FF2B5EF4-FFF2-40B4-BE49-F238E27FC236}">
+                <a16:creationId xmlns:a16="http://schemas.microsoft.com/office/drawing/2014/main" id="{707C2B88-C835-6886-7E10-C5E2893656FA}"/>
+              </a:ext>
+            </a:extLst>
+          </p:cNvPr>
+          <p:cNvSpPr/>
+          <p:nvPr/>
+        </p:nvSpPr>
+        <p:spPr>
+          <a:xfrm>
+            <a:off x="571500" y="1181100"/>
+            <a:ext cx="11049000" cy="38100"/>
+          </a:xfrm>
+          <a:prstGeom prst="rect">
+            <a:avLst/>
+          </a:prstGeom>
+          <a:solidFill>
+            <a:srgbClr val="0284C7"/>
+          </a:solidFill>
+          <a:ln>
+            <a:noFill/>
+          </a:ln>
+          <a:effectLst/>
+        </p:spPr>
+        <p:style>
+          <a:lnRef idx="1">
+            <a:schemeClr val="accent1"/>
+          </a:lnRef>
+          <a:fillRef idx="3">
+            <a:schemeClr val="accent1"/>
+          </a:fillRef>
+          <a:effectRef idx="2">
+            <a:schemeClr val="accent1"/>
+          </a:effectRef>
+          <a:fontRef idx="minor">
+            <a:schemeClr val="lt1"/>
+          </a:fontRef>
+        </p:style>
+        <p:txBody>
+          <a:bodyPr rtlCol="0" anchor="ctr"/>
+          <a:lstStyle/>
+          <a:p>
+            <a:pPr algn="ctr"/>
+            <a:endParaRPr/>
+          </a:p>
+        </p:txBody>
+      </p:sp>
+      <p:pic>
+        <p:nvPicPr>
+          <p:cNvPr id="13" name="Picture 12">
+            <a:extLst>
+              <a:ext uri="{FF2B5EF4-FFF2-40B4-BE49-F238E27FC236}">
+                <a16:creationId xmlns:a16="http://schemas.microsoft.com/office/drawing/2014/main" id="{CCD79E42-0582-4A24-1E72-7768CC7CEE14}"/>
+              </a:ext>
+            </a:extLst>
+          </p:cNvPr>
+          <p:cNvPicPr>
+            <a:picLocks noChangeAspect="1"/>
+          </p:cNvPicPr>
+          <p:nvPr/>
+        </p:nvPicPr>
+        <p:blipFill>
+          <a:blip r:embed="rId2"/>
+          <a:stretch>
+            <a:fillRect/>
+          </a:stretch>
+        </p:blipFill>
+        <p:spPr>
+          <a:xfrm>
+            <a:off x="137160" y="1763668"/>
+            <a:ext cx="11804904" cy="3330664"/>
+          </a:xfrm>
+          <a:prstGeom prst="rect">
+            <a:avLst/>
+          </a:prstGeom>
+        </p:spPr>
+      </p:pic>
+      <p:sp>
+        <p:nvSpPr>
+          <p:cNvPr id="14" name="TextBox 13">
+            <a:extLst>
+              <a:ext uri="{FF2B5EF4-FFF2-40B4-BE49-F238E27FC236}">
+                <a16:creationId xmlns:a16="http://schemas.microsoft.com/office/drawing/2014/main" id="{F1F81FCC-278E-ABD4-3F48-A30E454BB3F6}"/>
+              </a:ext>
+            </a:extLst>
+          </p:cNvPr>
+          <p:cNvSpPr txBox="1"/>
+          <p:nvPr/>
+        </p:nvSpPr>
+        <p:spPr>
+          <a:xfrm>
+            <a:off x="389572" y="5638800"/>
+            <a:ext cx="11300079" cy="906017"/>
+          </a:xfrm>
+          <a:prstGeom prst="rect">
+            <a:avLst/>
+          </a:prstGeom>
+          <a:noFill/>
+        </p:spPr>
+        <p:txBody>
+          <a:bodyPr wrap="square" lIns="0" tIns="0" rIns="0" bIns="0" anchor="t">
+            <a:spAutoFit/>
+          </a:bodyPr>
+          <a:lstStyle/>
+          <a:p>
+            <a:pPr algn="l">
+              <a:lnSpc>
+                <a:spcPts val="2400"/>
+              </a:lnSpc>
+            </a:pPr>
+            <a:r>
+              <a:rPr lang="en-US" b="0" i="0" u="none" dirty="0">
+                <a:solidFill>
+                  <a:srgbClr val="334155"/>
+                </a:solidFill>
+                <a:latin typeface="Open Sans"/>
+              </a:rPr>
+              <a:t>By maximizing the f1 score, the with highest recall is logistic regression (0.709), random forest is the one with highest precision 0.44, while </a:t>
+            </a:r>
+            <a:r>
+              <a:rPr lang="en-US" b="0" i="0" u="none" dirty="0" err="1">
+                <a:solidFill>
+                  <a:srgbClr val="334155"/>
+                </a:solidFill>
+                <a:latin typeface="Open Sans"/>
+              </a:rPr>
+              <a:t>lightgbm</a:t>
+            </a:r>
+            <a:r>
+              <a:rPr lang="en-US" b="0" i="0" u="none" dirty="0">
+                <a:solidFill>
+                  <a:srgbClr val="334155"/>
+                </a:solidFill>
+                <a:latin typeface="Open Sans"/>
+              </a:rPr>
+              <a:t> is the best balance by having the best f1 score 0.454</a:t>
+            </a:r>
+            <a:endParaRPr lang="en-US" dirty="0">
+              <a:solidFill>
+                <a:srgbClr val="334155"/>
+              </a:solidFill>
+              <a:latin typeface="Open Sans"/>
+            </a:endParaRPr>
+          </a:p>
+          <a:p>
+            <a:pPr algn="l">
+              <a:lnSpc>
+                <a:spcPts val="2400"/>
+              </a:lnSpc>
+            </a:pPr>
+            <a:endParaRPr b="0" i="0" u="none" dirty="0">
+              <a:solidFill>
+                <a:srgbClr val="334155"/>
+              </a:solidFill>
+              <a:latin typeface="Open Sans"/>
+            </a:endParaRPr>
+          </a:p>
+        </p:txBody>
+      </p:sp>
+    </p:spTree>
+    <p:extLst>
+      <p:ext uri="{BB962C8B-B14F-4D97-AF65-F5344CB8AC3E}">
+        <p14:creationId xmlns:p14="http://schemas.microsoft.com/office/powerpoint/2010/main" val="3775596006"/>
+      </p:ext>
+    </p:extLst>
+  </p:cSld>
+  <p:clrMapOvr>
+    <a:masterClrMapping/>
+  </p:clrMapOvr>
+</p:sld>
+</file>
+
+<file path=ppt/slides/slide13.xml><?xml version="1.0" encoding="utf-8"?>
 <p:sld xmlns:a="http://schemas.openxmlformats.org/drawingml/2006/main" xmlns:r="http://schemas.openxmlformats.org/officeDocument/2006/relationships" xmlns:p="http://schemas.openxmlformats.org/presentationml/2006/main">
   <p:cSld>
     <p:bg>
@@ -4316,7 +4830,7 @@
 </p:sld>
 </file>
 
-<file path=ppt/slides/slide13.xml><?xml version="1.0" encoding="utf-8"?>
+<file path=ppt/slides/slide14.xml><?xml version="1.0" encoding="utf-8"?>
 <p:sld xmlns:a="http://schemas.openxmlformats.org/drawingml/2006/main" xmlns:r="http://schemas.openxmlformats.org/officeDocument/2006/relationships" xmlns:p="http://schemas.openxmlformats.org/presentationml/2006/main">
   <p:cSld>
     <p:bg>
@@ -4627,7 +5141,7 @@
 </p:sld>
 </file>
 
-<file path=ppt/slides/slide14.xml><?xml version="1.0" encoding="utf-8"?>
+<file path=ppt/slides/slide15.xml><?xml version="1.0" encoding="utf-8"?>
 <p:sld xmlns:a="http://schemas.openxmlformats.org/drawingml/2006/main" xmlns:r="http://schemas.openxmlformats.org/officeDocument/2006/relationships" xmlns:p="http://schemas.openxmlformats.org/presentationml/2006/main">
   <p:cSld>
     <p:spTree>
@@ -4644,30 +5158,6 @@
           <a:chExt cx="0" cy="0"/>
         </a:xfrm>
       </p:grpSpPr>
-      <p:pic>
-        <p:nvPicPr>
-          <p:cNvPr id="2" name="Picture 1" descr="image.png"/>
-          <p:cNvPicPr>
-            <a:picLocks noChangeAspect="1"/>
-          </p:cNvPicPr>
-          <p:nvPr/>
-        </p:nvPicPr>
-        <p:blipFill>
-          <a:blip r:embed="rId2"/>
-          <a:stretch>
-            <a:fillRect/>
-          </a:stretch>
-        </p:blipFill>
-        <p:spPr>
-          <a:xfrm>
-            <a:off x="0" y="0"/>
-            <a:ext cx="12192000" cy="6858000"/>
-          </a:xfrm>
-          <a:prstGeom prst="rect">
-            <a:avLst/>
-          </a:prstGeom>
-        </p:spPr>
-      </p:pic>
       <p:sp>
         <p:nvSpPr>
           <p:cNvPr id="3" name="TextBox 2"/>
@@ -4676,7 +5166,7 @@
         </p:nvSpPr>
         <p:spPr>
           <a:xfrm>
-            <a:off x="1595437" y="2342257"/>
+            <a:off x="1805749" y="705290"/>
             <a:ext cx="9001125" cy="695325"/>
           </a:xfrm>
           <a:prstGeom prst="rect">
@@ -4692,13 +5182,13 @@
           <a:p>
             <a:pPr algn="ctr"/>
             <a:r>
-              <a:rPr sz="4500" b="1" i="0" u="none">
+              <a:rPr sz="4500" b="1" i="0" u="none" dirty="0">
                 <a:solidFill>
                   <a:srgbClr val="0F172A"/>
                 </a:solidFill>
                 <a:latin typeface="Montserrat"/>
               </a:rPr>
-              <a:t>Conclusion &amp; Deployment</a:t>
+              <a:t>Conclusion</a:t>
             </a:r>
           </a:p>
         </p:txBody>
@@ -4711,8 +5201,8 @@
         </p:nvSpPr>
         <p:spPr>
           <a:xfrm>
-            <a:off x="1809750" y="3228082"/>
-            <a:ext cx="8572500" cy="1097012"/>
+            <a:off x="1078992" y="1777237"/>
+            <a:ext cx="9303258" cy="3685624"/>
           </a:xfrm>
           <a:prstGeom prst="rect">
             <a:avLst/>
@@ -4725,20 +5215,208 @@
           </a:bodyPr>
           <a:lstStyle/>
           <a:p>
-            <a:pPr algn="ctr">
+            <a:pPr marL="285750" indent="-285750">
               <a:lnSpc>
                 <a:spcPts val="2879"/>
               </a:lnSpc>
+              <a:buFont typeface="Arial" panose="020B0604020202020204" pitchFamily="34" charset="0"/>
+              <a:buChar char="•"/>
             </a:pPr>
             <a:r>
-              <a:rPr sz="1800" b="0" i="0" u="none">
+              <a:rPr lang="en-US" sz="2000" dirty="0">
                 <a:solidFill>
                   <a:srgbClr val="0F172A"/>
                 </a:solidFill>
                 <a:latin typeface="Open Sans"/>
               </a:rPr>
-              <a:t>By standardizing data extraction, aggressively engineering clinical features, and utilizing automated hyperparameter tuning (Optuna), we successfully elevated our predictive F1-score from 0.13 to 0.47 on highly imbalanced critical care data.</a:t>
-            </a:r>
+              <a:t>The most important variable increasing the risk of mortality in women is length of stay, more days in ICU are related to a higher probability of death, followed by age and pregnancy condition.</a:t>
+            </a:r>
+          </a:p>
+          <a:p>
+            <a:pPr marL="285750" indent="-285750">
+              <a:lnSpc>
+                <a:spcPts val="2879"/>
+              </a:lnSpc>
+              <a:buFont typeface="Arial" panose="020B0604020202020204" pitchFamily="34" charset="0"/>
+              <a:buChar char="•"/>
+            </a:pPr>
+            <a:endParaRPr lang="en-US" sz="2000" b="0" i="0" u="none" dirty="0">
+              <a:solidFill>
+                <a:srgbClr val="0F172A"/>
+              </a:solidFill>
+              <a:latin typeface="Open Sans"/>
+            </a:endParaRPr>
+          </a:p>
+          <a:p>
+            <a:pPr marL="285750" indent="-285750">
+              <a:lnSpc>
+                <a:spcPts val="2879"/>
+              </a:lnSpc>
+              <a:buFont typeface="Arial" panose="020B0604020202020204" pitchFamily="34" charset="0"/>
+              <a:buChar char="•"/>
+            </a:pPr>
+            <a:r>
+              <a:rPr sz="2000" b="0" i="0" u="none" dirty="0">
+                <a:solidFill>
+                  <a:srgbClr val="0F172A"/>
+                </a:solidFill>
+                <a:latin typeface="Open Sans"/>
+              </a:rPr>
+              <a:t>By data extraction,</a:t>
+            </a:r>
+            <a:r>
+              <a:rPr lang="en-US" sz="2000" b="0" i="0" u="none" dirty="0">
+                <a:solidFill>
+                  <a:srgbClr val="0F172A"/>
+                </a:solidFill>
+                <a:latin typeface="Open Sans"/>
+              </a:rPr>
+              <a:t> preprocessing</a:t>
+            </a:r>
+            <a:r>
+              <a:rPr sz="2000" b="0" i="0" u="none" dirty="0">
+                <a:solidFill>
+                  <a:srgbClr val="0F172A"/>
+                </a:solidFill>
+                <a:latin typeface="Open Sans"/>
+              </a:rPr>
+              <a:t> engineering clinical features, and utilizing hyperparameter tuning (</a:t>
+            </a:r>
+            <a:r>
+              <a:rPr sz="2000" b="0" i="0" u="none" dirty="0" err="1">
+                <a:solidFill>
+                  <a:srgbClr val="0F172A"/>
+                </a:solidFill>
+                <a:latin typeface="Open Sans"/>
+              </a:rPr>
+              <a:t>Optuna</a:t>
+            </a:r>
+            <a:r>
+              <a:rPr sz="2000" b="0" i="0" u="none" dirty="0">
+                <a:solidFill>
+                  <a:srgbClr val="0F172A"/>
+                </a:solidFill>
+                <a:latin typeface="Open Sans"/>
+              </a:rPr>
+              <a:t>), </a:t>
+            </a:r>
+            <a:r>
+              <a:rPr lang="en-US" sz="2000" dirty="0">
+                <a:solidFill>
+                  <a:srgbClr val="0F172A"/>
+                </a:solidFill>
+                <a:latin typeface="Open Sans"/>
+              </a:rPr>
+              <a:t>the</a:t>
+            </a:r>
+            <a:r>
+              <a:rPr sz="2000" b="0" i="0" u="none" dirty="0">
+                <a:solidFill>
+                  <a:srgbClr val="0F172A"/>
+                </a:solidFill>
+                <a:latin typeface="Open Sans"/>
+              </a:rPr>
+              <a:t> predictive F1-score </a:t>
+            </a:r>
+            <a:r>
+              <a:rPr lang="en-US" sz="2000" b="0" i="0" u="none" dirty="0">
+                <a:solidFill>
+                  <a:srgbClr val="0F172A"/>
+                </a:solidFill>
+                <a:latin typeface="Open Sans"/>
+              </a:rPr>
+              <a:t>elevated </a:t>
+            </a:r>
+            <a:r>
+              <a:rPr sz="2000" b="0" i="0" u="none" dirty="0">
+                <a:solidFill>
+                  <a:srgbClr val="0F172A"/>
+                </a:solidFill>
+                <a:latin typeface="Open Sans"/>
+              </a:rPr>
+              <a:t>from 0.13 to 0.4</a:t>
+            </a:r>
+            <a:r>
+              <a:rPr lang="en-US" sz="2000" b="0" i="0" u="none" dirty="0">
+                <a:solidFill>
+                  <a:srgbClr val="0F172A"/>
+                </a:solidFill>
+                <a:latin typeface="Open Sans"/>
+              </a:rPr>
+              <a:t>5</a:t>
+            </a:r>
+            <a:r>
+              <a:rPr sz="2000" b="0" i="0" u="none" dirty="0">
+                <a:solidFill>
+                  <a:srgbClr val="0F172A"/>
+                </a:solidFill>
+                <a:latin typeface="Open Sans"/>
+              </a:rPr>
+              <a:t> on highly imbalanced critical care data.</a:t>
+            </a:r>
+            <a:endParaRPr lang="en-US" sz="2000" b="0" i="0" u="none" dirty="0">
+              <a:solidFill>
+                <a:srgbClr val="0F172A"/>
+              </a:solidFill>
+              <a:latin typeface="Open Sans"/>
+            </a:endParaRPr>
+          </a:p>
+          <a:p>
+            <a:pPr marL="285750" indent="-285750">
+              <a:lnSpc>
+                <a:spcPts val="2879"/>
+              </a:lnSpc>
+              <a:buFont typeface="Arial" panose="020B0604020202020204" pitchFamily="34" charset="0"/>
+              <a:buChar char="•"/>
+            </a:pPr>
+            <a:endParaRPr lang="en-US" sz="2000" dirty="0">
+              <a:solidFill>
+                <a:srgbClr val="0F172A"/>
+              </a:solidFill>
+              <a:latin typeface="Open Sans"/>
+            </a:endParaRPr>
+          </a:p>
+          <a:p>
+            <a:pPr marL="285750" indent="-285750">
+              <a:lnSpc>
+                <a:spcPts val="2879"/>
+              </a:lnSpc>
+              <a:buFont typeface="Arial" panose="020B0604020202020204" pitchFamily="34" charset="0"/>
+              <a:buChar char="•"/>
+            </a:pPr>
+            <a:r>
+              <a:rPr lang="en-US" sz="2000" b="0" i="0" u="none" dirty="0">
+                <a:solidFill>
+                  <a:srgbClr val="0F172A"/>
+                </a:solidFill>
+                <a:latin typeface="Open Sans"/>
+              </a:rPr>
+              <a:t>The best model was </a:t>
+            </a:r>
+            <a:r>
+              <a:rPr lang="en-US" sz="2000" b="0" i="0" u="none" dirty="0" err="1">
+                <a:solidFill>
+                  <a:srgbClr val="0F172A"/>
+                </a:solidFill>
+                <a:latin typeface="Open Sans"/>
+              </a:rPr>
+              <a:t>LightGBM</a:t>
+            </a:r>
+            <a:r>
+              <a:rPr lang="en-US" sz="2000" b="0" i="0" u="none" dirty="0">
+                <a:solidFill>
+                  <a:srgbClr val="0F172A"/>
+                </a:solidFill>
+                <a:latin typeface="Open Sans"/>
+              </a:rPr>
+              <a:t> which let the F1-score metric, followed by random forest by small difference (0.44).</a:t>
+            </a:r>
+            <a:endParaRPr sz="2000" b="0" i="0" u="none" dirty="0">
+              <a:solidFill>
+                <a:srgbClr val="0F172A"/>
+              </a:solidFill>
+              <a:latin typeface="Open Sans"/>
+            </a:endParaRPr>
           </a:p>
         </p:txBody>
       </p:sp>
@@ -5601,88 +6279,16 @@
           </a:prstGeom>
         </p:spPr>
       </p:pic>
-      <p:pic>
-        <p:nvPicPr>
-          <p:cNvPr id="3" name="Picture 2" descr="image.png"/>
-          <p:cNvPicPr>
-            <a:picLocks noChangeAspect="1"/>
-          </p:cNvPicPr>
-          <p:nvPr/>
-        </p:nvPicPr>
-        <p:blipFill>
-          <a:blip r:embed="rId3"/>
-          <a:stretch>
-            <a:fillRect/>
-          </a:stretch>
-        </p:blipFill>
-        <p:spPr>
-          <a:xfrm>
-            <a:off x="571500" y="2176462"/>
-            <a:ext cx="3429000" cy="3533775"/>
-          </a:xfrm>
-          <a:prstGeom prst="rect">
-            <a:avLst/>
-          </a:prstGeom>
-        </p:spPr>
-      </p:pic>
-      <p:pic>
-        <p:nvPicPr>
-          <p:cNvPr id="4" name="Picture 3" descr="image.png"/>
-          <p:cNvPicPr>
-            <a:picLocks noChangeAspect="1"/>
-          </p:cNvPicPr>
-          <p:nvPr/>
-        </p:nvPicPr>
-        <p:blipFill>
-          <a:blip r:embed="rId4"/>
-          <a:stretch>
-            <a:fillRect/>
-          </a:stretch>
-        </p:blipFill>
-        <p:spPr>
-          <a:xfrm>
-            <a:off x="4381500" y="2176462"/>
-            <a:ext cx="3429000" cy="3533775"/>
-          </a:xfrm>
-          <a:prstGeom prst="rect">
-            <a:avLst/>
-          </a:prstGeom>
-        </p:spPr>
-      </p:pic>
-      <p:pic>
-        <p:nvPicPr>
-          <p:cNvPr id="5" name="Picture 4" descr="image.png"/>
-          <p:cNvPicPr>
-            <a:picLocks noChangeAspect="1"/>
-          </p:cNvPicPr>
-          <p:nvPr/>
-        </p:nvPicPr>
-        <p:blipFill>
-          <a:blip r:embed="rId5"/>
-          <a:stretch>
-            <a:fillRect/>
-          </a:stretch>
-        </p:blipFill>
-        <p:spPr>
-          <a:xfrm>
-            <a:off x="8191500" y="2176462"/>
-            <a:ext cx="3429000" cy="3533775"/>
-          </a:xfrm>
-          <a:prstGeom prst="rect">
-            <a:avLst/>
-          </a:prstGeom>
-        </p:spPr>
-      </p:pic>
-      <p:sp>
-        <p:nvSpPr>
-          <p:cNvPr id="6" name="TextBox 5"/>
+      <p:sp>
+        <p:nvSpPr>
+          <p:cNvPr id="7" name="TextBox 6"/>
           <p:cNvSpPr txBox="1"/>
           <p:nvPr/>
         </p:nvSpPr>
         <p:spPr>
           <a:xfrm>
-            <a:off x="1290875" y="3281362"/>
-            <a:ext cx="1990248" cy="323850"/>
+            <a:off x="793622" y="1974151"/>
+            <a:ext cx="5652898" cy="3983783"/>
           </a:xfrm>
           <a:prstGeom prst="rect">
             <a:avLst/>
@@ -5695,278 +6301,172 @@
           </a:bodyPr>
           <a:lstStyle/>
           <a:p>
-            <a:pPr algn="ctr"/>
-            <a:r>
-              <a:rPr sz="2100" b="0" i="0" u="none">
-                <a:solidFill>
-                  <a:srgbClr val="0284C7"/>
-                </a:solidFill>
-                <a:latin typeface="Montserrat SemiBold"/>
-              </a:rPr>
-              <a:t>Null Handling</a:t>
-            </a:r>
-          </a:p>
-        </p:txBody>
-      </p:sp>
-      <p:sp>
-        <p:nvSpPr>
-          <p:cNvPr id="7" name="TextBox 6"/>
-          <p:cNvSpPr txBox="1"/>
-          <p:nvPr/>
-        </p:nvSpPr>
-        <p:spPr>
-          <a:xfrm>
-            <a:off x="866775" y="3748087"/>
-            <a:ext cx="2838450" cy="1524000"/>
-          </a:xfrm>
-          <a:prstGeom prst="rect">
-            <a:avLst/>
-          </a:prstGeom>
-          <a:noFill/>
-        </p:spPr>
-        <p:txBody>
-          <a:bodyPr wrap="square" lIns="0" tIns="0" rIns="0" bIns="0" anchor="t">
-            <a:spAutoFit/>
-          </a:bodyPr>
-          <a:lstStyle/>
-          <a:p>
-            <a:pPr algn="ctr">
+            <a:pPr marL="285750" indent="-285750">
               <a:lnSpc>
                 <a:spcPts val="2400"/>
               </a:lnSpc>
+              <a:buFont typeface="Arial" panose="020B0604020202020204" pitchFamily="34" charset="0"/>
+              <a:buChar char="•"/>
             </a:pPr>
             <a:r>
-              <a:rPr sz="1500" b="0" i="0" u="none">
+              <a:rPr lang="en-US" b="0" i="0" u="none" dirty="0">
                 <a:solidFill>
                   <a:srgbClr val="334155"/>
                 </a:solidFill>
                 <a:latin typeface="Open Sans"/>
               </a:rPr>
-              <a:t>Calculated null percentages for all variables. Dropped columns exceeding 20% missing values (e.g., avg_sys_bp, avg_dias_bp, avg_temp).</a:t>
-            </a:r>
-          </a:p>
-        </p:txBody>
-      </p:sp>
-      <p:sp>
-        <p:nvSpPr>
-          <p:cNvPr id="8" name="TextBox 7"/>
-          <p:cNvSpPr txBox="1"/>
-          <p:nvPr/>
-        </p:nvSpPr>
-        <p:spPr>
-          <a:xfrm>
-            <a:off x="4735830" y="3281362"/>
-            <a:ext cx="2720340" cy="323850"/>
-          </a:xfrm>
-          <a:prstGeom prst="rect">
-            <a:avLst/>
-          </a:prstGeom>
-          <a:noFill/>
-        </p:spPr>
-        <p:txBody>
-          <a:bodyPr wrap="square" lIns="0" tIns="0" rIns="0" bIns="0" anchor="t">
-            <a:spAutoFit/>
-          </a:bodyPr>
-          <a:lstStyle/>
-          <a:p>
-            <a:pPr algn="ctr"/>
-            <a:r>
-              <a:rPr sz="2100" b="0" i="0" u="none">
-                <a:solidFill>
-                  <a:srgbClr val="0284C7"/>
-                </a:solidFill>
-                <a:latin typeface="Montserrat SemiBold"/>
-              </a:rPr>
-              <a:t>Calculated Metrics</a:t>
-            </a:r>
-          </a:p>
-        </p:txBody>
-      </p:sp>
-      <p:sp>
-        <p:nvSpPr>
-          <p:cNvPr id="9" name="TextBox 8"/>
-          <p:cNvSpPr txBox="1"/>
-          <p:nvPr/>
-        </p:nvSpPr>
-        <p:spPr>
-          <a:xfrm>
-            <a:off x="4676775" y="3748087"/>
-            <a:ext cx="2838450" cy="1524000"/>
-          </a:xfrm>
-          <a:prstGeom prst="rect">
-            <a:avLst/>
-          </a:prstGeom>
-          <a:noFill/>
-        </p:spPr>
-        <p:txBody>
-          <a:bodyPr wrap="square" lIns="0" tIns="0" rIns="0" bIns="0" anchor="t">
-            <a:spAutoFit/>
-          </a:bodyPr>
-          <a:lstStyle/>
-          <a:p>
-            <a:pPr algn="ctr">
+              <a:t>Null Handling: </a:t>
+            </a:r>
+            <a:r>
+              <a:rPr b="0" i="0" u="none" dirty="0">
+                <a:solidFill>
+                  <a:srgbClr val="334155"/>
+                </a:solidFill>
+                <a:latin typeface="Open Sans"/>
+              </a:rPr>
+              <a:t>Calculated null percentages for all variables. Dropped columns exceeding 20% missing values</a:t>
+            </a:r>
+            <a:endParaRPr lang="en-US" b="0" i="0" u="none" dirty="0">
+              <a:solidFill>
+                <a:srgbClr val="334155"/>
+              </a:solidFill>
+              <a:latin typeface="Open Sans"/>
+            </a:endParaRPr>
+          </a:p>
+          <a:p>
+            <a:pPr marL="285750" indent="-285750">
               <a:lnSpc>
                 <a:spcPts val="2400"/>
               </a:lnSpc>
+              <a:buFont typeface="Arial" panose="020B0604020202020204" pitchFamily="34" charset="0"/>
+              <a:buChar char="•"/>
             </a:pPr>
-            <a:r>
-              <a:rPr sz="1500" b="0" i="0" u="none">
-                <a:solidFill>
-                  <a:srgbClr val="334155"/>
-                </a:solidFill>
-                <a:latin typeface="Open Sans"/>
-              </a:rPr>
-              <a:t>Engineered critical time-based metrics. Computed 'length_of_stay' (days) and 'age_at_admission' (years) using admission and discharge dates.</a:t>
-            </a:r>
-          </a:p>
-        </p:txBody>
-      </p:sp>
-      <p:sp>
-        <p:nvSpPr>
-          <p:cNvPr id="10" name="TextBox 9"/>
-          <p:cNvSpPr txBox="1"/>
-          <p:nvPr/>
-        </p:nvSpPr>
-        <p:spPr>
-          <a:xfrm>
-            <a:off x="8775858" y="3281362"/>
-            <a:ext cx="2260282" cy="323850"/>
-          </a:xfrm>
-          <a:prstGeom prst="rect">
-            <a:avLst/>
-          </a:prstGeom>
-          <a:noFill/>
-        </p:spPr>
-        <p:txBody>
-          <a:bodyPr wrap="square" lIns="0" tIns="0" rIns="0" bIns="0" anchor="t">
-            <a:spAutoFit/>
-          </a:bodyPr>
-          <a:lstStyle/>
-          <a:p>
-            <a:pPr algn="ctr"/>
-            <a:r>
-              <a:rPr sz="2100" b="0" i="0" u="none">
-                <a:solidFill>
-                  <a:srgbClr val="0284C7"/>
-                </a:solidFill>
-                <a:latin typeface="Montserrat SemiBold"/>
-              </a:rPr>
-              <a:t>ICD-9 Grouping</a:t>
-            </a:r>
-          </a:p>
-        </p:txBody>
-      </p:sp>
-      <p:sp>
-        <p:nvSpPr>
-          <p:cNvPr id="11" name="TextBox 10"/>
-          <p:cNvSpPr txBox="1"/>
-          <p:nvPr/>
-        </p:nvSpPr>
-        <p:spPr>
-          <a:xfrm>
-            <a:off x="8486775" y="3748087"/>
-            <a:ext cx="2838450" cy="1524000"/>
-          </a:xfrm>
-          <a:prstGeom prst="rect">
-            <a:avLst/>
-          </a:prstGeom>
-          <a:noFill/>
-        </p:spPr>
-        <p:txBody>
-          <a:bodyPr wrap="square" lIns="0" tIns="0" rIns="0" bIns="0" anchor="t">
-            <a:spAutoFit/>
-          </a:bodyPr>
-          <a:lstStyle/>
-          <a:p>
-            <a:pPr algn="ctr">
+            <a:endParaRPr lang="en-US" dirty="0">
+              <a:solidFill>
+                <a:srgbClr val="334155"/>
+              </a:solidFill>
+              <a:latin typeface="Open Sans"/>
+            </a:endParaRPr>
+          </a:p>
+          <a:p>
+            <a:pPr marL="285750" indent="-285750">
               <a:lnSpc>
                 <a:spcPts val="2400"/>
               </a:lnSpc>
+              <a:buFont typeface="Arial" panose="020B0604020202020204" pitchFamily="34" charset="0"/>
+              <a:buChar char="•"/>
             </a:pPr>
             <a:r>
-              <a:rPr sz="1500" b="0" i="0" u="none">
+              <a:rPr lang="en-US" dirty="0">
                 <a:solidFill>
                   <a:srgbClr val="334155"/>
                 </a:solidFill>
                 <a:latin typeface="Open Sans"/>
               </a:rPr>
-              <a:t>Simplified complex ICD-9 diagnosis codes into 18 broader medical categories (e.g., infectious, neoplasms, respiratory, cardiovascular).</a:t>
-            </a:r>
-          </a:p>
-        </p:txBody>
-      </p:sp>
-      <p:pic>
-        <p:nvPicPr>
-          <p:cNvPr id="12" name="Picture 11" descr="image.png"/>
-          <p:cNvPicPr>
-            <a:picLocks noChangeAspect="1"/>
-          </p:cNvPicPr>
-          <p:nvPr/>
-        </p:nvPicPr>
-        <p:blipFill>
-          <a:blip r:embed="rId6"/>
-          <a:stretch>
-            <a:fillRect/>
-          </a:stretch>
-        </p:blipFill>
-        <p:spPr>
-          <a:xfrm>
-            <a:off x="2028825" y="2557462"/>
-            <a:ext cx="514350" cy="457200"/>
-          </a:xfrm>
-          <a:prstGeom prst="rect">
-            <a:avLst/>
-          </a:prstGeom>
-        </p:spPr>
-      </p:pic>
-      <p:pic>
-        <p:nvPicPr>
-          <p:cNvPr id="13" name="Picture 12" descr="image.png"/>
-          <p:cNvPicPr>
-            <a:picLocks noChangeAspect="1"/>
-          </p:cNvPicPr>
-          <p:nvPr/>
-        </p:nvPicPr>
-        <p:blipFill>
-          <a:blip r:embed="rId7"/>
-          <a:stretch>
-            <a:fillRect/>
-          </a:stretch>
-        </p:blipFill>
-        <p:spPr>
-          <a:xfrm>
-            <a:off x="5895975" y="2557462"/>
-            <a:ext cx="400050" cy="457200"/>
-          </a:xfrm>
-          <a:prstGeom prst="rect">
-            <a:avLst/>
-          </a:prstGeom>
-        </p:spPr>
-      </p:pic>
-      <p:pic>
-        <p:nvPicPr>
-          <p:cNvPr id="14" name="Picture 13" descr="image.png"/>
-          <p:cNvPicPr>
-            <a:picLocks noChangeAspect="1"/>
-          </p:cNvPicPr>
-          <p:nvPr/>
-        </p:nvPicPr>
-        <p:blipFill>
-          <a:blip r:embed="rId8"/>
-          <a:stretch>
-            <a:fillRect/>
-          </a:stretch>
-        </p:blipFill>
-        <p:spPr>
-          <a:xfrm>
-            <a:off x="9648825" y="2557462"/>
-            <a:ext cx="514350" cy="457200"/>
-          </a:xfrm>
-          <a:prstGeom prst="rect">
-            <a:avLst/>
-          </a:prstGeom>
-        </p:spPr>
-      </p:pic>
+              <a:t>Calculated Metrics: Engineered critical time-based metrics. Computed '</a:t>
+            </a:r>
+            <a:r>
+              <a:rPr lang="en-US" dirty="0" err="1">
+                <a:solidFill>
+                  <a:srgbClr val="334155"/>
+                </a:solidFill>
+                <a:latin typeface="Open Sans"/>
+              </a:rPr>
+              <a:t>length_of_stay</a:t>
+            </a:r>
+            <a:r>
+              <a:rPr lang="en-US" dirty="0">
+                <a:solidFill>
+                  <a:srgbClr val="334155"/>
+                </a:solidFill>
+                <a:latin typeface="Open Sans"/>
+              </a:rPr>
+              <a:t>’, and '</a:t>
+            </a:r>
+            <a:r>
+              <a:rPr lang="en-US" dirty="0" err="1">
+                <a:solidFill>
+                  <a:srgbClr val="334155"/>
+                </a:solidFill>
+                <a:latin typeface="Open Sans"/>
+              </a:rPr>
+              <a:t>age_at_admission</a:t>
+            </a:r>
+            <a:r>
+              <a:rPr lang="en-US" dirty="0">
+                <a:solidFill>
+                  <a:srgbClr val="334155"/>
+                </a:solidFill>
+                <a:latin typeface="Open Sans"/>
+              </a:rPr>
+              <a:t>’.</a:t>
+            </a:r>
+          </a:p>
+          <a:p>
+            <a:pPr marL="285750" indent="-285750">
+              <a:lnSpc>
+                <a:spcPts val="2400"/>
+              </a:lnSpc>
+              <a:buFont typeface="Arial" panose="020B0604020202020204" pitchFamily="34" charset="0"/>
+              <a:buChar char="•"/>
+            </a:pPr>
+            <a:endParaRPr lang="en-US" dirty="0">
+              <a:solidFill>
+                <a:srgbClr val="334155"/>
+              </a:solidFill>
+              <a:latin typeface="Open Sans"/>
+            </a:endParaRPr>
+          </a:p>
+          <a:p>
+            <a:pPr marL="285750" indent="-285750">
+              <a:lnSpc>
+                <a:spcPts val="2400"/>
+              </a:lnSpc>
+              <a:buFont typeface="Arial" panose="020B0604020202020204" pitchFamily="34" charset="0"/>
+              <a:buChar char="•"/>
+            </a:pPr>
+            <a:r>
+              <a:rPr lang="en-US" dirty="0">
+                <a:solidFill>
+                  <a:srgbClr val="334155"/>
+                </a:solidFill>
+                <a:latin typeface="Open Sans"/>
+              </a:rPr>
+              <a:t>ICD-9 Grouping: Simplified complex ICD-9 diagnosis codes into 18 broader medical categories</a:t>
+            </a:r>
+          </a:p>
+          <a:p>
+            <a:pPr marL="285750" indent="-285750">
+              <a:lnSpc>
+                <a:spcPts val="2400"/>
+              </a:lnSpc>
+              <a:buFont typeface="Arial" panose="020B0604020202020204" pitchFamily="34" charset="0"/>
+              <a:buChar char="•"/>
+            </a:pPr>
+            <a:endParaRPr lang="en-US" dirty="0">
+              <a:solidFill>
+                <a:srgbClr val="334155"/>
+              </a:solidFill>
+              <a:latin typeface="Open Sans"/>
+            </a:endParaRPr>
+          </a:p>
+          <a:p>
+            <a:pPr marL="285750" indent="-285750">
+              <a:lnSpc>
+                <a:spcPts val="2400"/>
+              </a:lnSpc>
+              <a:buFont typeface="Arial" panose="020B0604020202020204" pitchFamily="34" charset="0"/>
+              <a:buChar char="•"/>
+            </a:pPr>
+            <a:endParaRPr b="0" i="0" u="none" dirty="0">
+              <a:solidFill>
+                <a:srgbClr val="334155"/>
+              </a:solidFill>
+              <a:latin typeface="Open Sans"/>
+            </a:endParaRPr>
+          </a:p>
+        </p:txBody>
+      </p:sp>
       <p:sp>
         <p:nvSpPr>
           <p:cNvPr id="15" name="TextBox 14"/>
@@ -6047,6 +6547,36 @@
           </a:p>
         </p:txBody>
       </p:sp>
+      <p:pic>
+        <p:nvPicPr>
+          <p:cNvPr id="18" name="Picture 17">
+            <a:extLst>
+              <a:ext uri="{FF2B5EF4-FFF2-40B4-BE49-F238E27FC236}">
+                <a16:creationId xmlns:a16="http://schemas.microsoft.com/office/drawing/2014/main" id="{BCE55053-F517-4676-F80C-D4977BCFA1FB}"/>
+              </a:ext>
+            </a:extLst>
+          </p:cNvPr>
+          <p:cNvPicPr>
+            <a:picLocks noChangeAspect="1"/>
+          </p:cNvPicPr>
+          <p:nvPr/>
+        </p:nvPicPr>
+        <p:blipFill>
+          <a:blip r:embed="rId3"/>
+          <a:stretch>
+            <a:fillRect/>
+          </a:stretch>
+        </p:blipFill>
+        <p:spPr>
+          <a:xfrm>
+            <a:off x="6766561" y="2269796"/>
+            <a:ext cx="4771644" cy="2997147"/>
+          </a:xfrm>
+          <a:prstGeom prst="rect">
+            <a:avLst/>
+          </a:prstGeom>
+        </p:spPr>
+      </p:pic>
     </p:spTree>
   </p:cSld>
   <p:clrMapOvr>
@@ -6080,113 +6610,6 @@
           <a:chExt cx="0" cy="0"/>
         </a:xfrm>
       </p:grpSpPr>
-      <p:pic>
-        <p:nvPicPr>
-          <p:cNvPr id="2" name="Picture 1" descr="image.png"/>
-          <p:cNvPicPr>
-            <a:picLocks noChangeAspect="1"/>
-          </p:cNvPicPr>
-          <p:nvPr/>
-        </p:nvPicPr>
-        <p:blipFill>
-          <a:blip r:embed="rId2"/>
-          <a:stretch>
-            <a:fillRect/>
-          </a:stretch>
-        </p:blipFill>
-        <p:spPr>
-          <a:xfrm>
-            <a:off x="0" y="0"/>
-            <a:ext cx="12192000" cy="6858000"/>
-          </a:xfrm>
-          <a:prstGeom prst="rect">
-            <a:avLst/>
-          </a:prstGeom>
-        </p:spPr>
-      </p:pic>
-      <p:pic>
-        <p:nvPicPr>
-          <p:cNvPr id="3" name="Picture 2" descr="image.png"/>
-          <p:cNvPicPr>
-            <a:picLocks noChangeAspect="1"/>
-          </p:cNvPicPr>
-          <p:nvPr/>
-        </p:nvPicPr>
-        <p:blipFill>
-          <a:blip r:embed="rId3"/>
-          <a:stretch>
-            <a:fillRect/>
-          </a:stretch>
-        </p:blipFill>
-        <p:spPr>
-          <a:xfrm>
-            <a:off x="571500" y="2486025"/>
-            <a:ext cx="5286375" cy="2914650"/>
-          </a:xfrm>
-          <a:prstGeom prst="rect">
-            <a:avLst/>
-          </a:prstGeom>
-        </p:spPr>
-      </p:pic>
-      <p:pic>
-        <p:nvPicPr>
-          <p:cNvPr id="4" name="Picture 3" descr="image.png"/>
-          <p:cNvPicPr>
-            <a:picLocks noChangeAspect="1"/>
-          </p:cNvPicPr>
-          <p:nvPr/>
-        </p:nvPicPr>
-        <p:blipFill>
-          <a:blip r:embed="rId4"/>
-          <a:stretch>
-            <a:fillRect/>
-          </a:stretch>
-        </p:blipFill>
-        <p:spPr>
-          <a:xfrm>
-            <a:off x="6334125" y="2486025"/>
-            <a:ext cx="5286375" cy="2914650"/>
-          </a:xfrm>
-          <a:prstGeom prst="rect">
-            <a:avLst/>
-          </a:prstGeom>
-        </p:spPr>
-      </p:pic>
-      <p:sp>
-        <p:nvSpPr>
-          <p:cNvPr id="5" name="TextBox 4"/>
-          <p:cNvSpPr txBox="1"/>
-          <p:nvPr/>
-        </p:nvSpPr>
-        <p:spPr>
-          <a:xfrm>
-            <a:off x="962025" y="2876550"/>
-            <a:ext cx="4730591" cy="323850"/>
-          </a:xfrm>
-          <a:prstGeom prst="rect">
-            <a:avLst/>
-          </a:prstGeom>
-          <a:noFill/>
-        </p:spPr>
-        <p:txBody>
-          <a:bodyPr wrap="square" lIns="0" tIns="0" rIns="0" bIns="0" anchor="t">
-            <a:spAutoFit/>
-          </a:bodyPr>
-          <a:lstStyle/>
-          <a:p>
-            <a:pPr algn="l"/>
-            <a:r>
-              <a:rPr sz="2100" b="0" i="0" u="none">
-                <a:solidFill>
-                  <a:srgbClr val="0284C7"/>
-                </a:solidFill>
-                <a:latin typeface="Montserrat SemiBold"/>
-              </a:rPr>
-              <a:t>Religion Normalization</a:t>
-            </a:r>
-          </a:p>
-        </p:txBody>
-      </p:sp>
       <p:sp>
         <p:nvSpPr>
           <p:cNvPr id="6" name="TextBox 5"/>
@@ -6195,8 +6618,8 @@
         </p:nvSpPr>
         <p:spPr>
           <a:xfrm>
-            <a:off x="962025" y="3343275"/>
-            <a:ext cx="4505325" cy="1524000"/>
+            <a:off x="742569" y="1804391"/>
+            <a:ext cx="6261735" cy="3368230"/>
           </a:xfrm>
           <a:prstGeom prst="rect">
             <a:avLst/>
@@ -6215,88 +6638,92 @@
               </a:lnSpc>
             </a:pPr>
             <a:r>
-              <a:rPr sz="1500" b="0" i="0" u="none">
+              <a:rPr lang="en-US" b="0" i="0" u="none" dirty="0">
                 <a:solidFill>
                   <a:srgbClr val="334155"/>
                 </a:solidFill>
                 <a:latin typeface="Open Sans"/>
               </a:rPr>
-              <a:t>The dataset contained multiple fragmented religious affiliations. We utilized RegEx patterns to group these responses into a binary 'RELIGIOUS' vs. 'NOT RELIGIOUS' flag, enhancing the model's ability to process the feature.</a:t>
-            </a:r>
-          </a:p>
-        </p:txBody>
-      </p:sp>
-      <p:sp>
-        <p:nvSpPr>
-          <p:cNvPr id="7" name="TextBox 6"/>
-          <p:cNvSpPr txBox="1"/>
-          <p:nvPr/>
-        </p:nvSpPr>
-        <p:spPr>
-          <a:xfrm>
-            <a:off x="6724650" y="2876550"/>
-            <a:ext cx="4730591" cy="323850"/>
-          </a:xfrm>
-          <a:prstGeom prst="rect">
-            <a:avLst/>
-          </a:prstGeom>
-          <a:noFill/>
-        </p:spPr>
-        <p:txBody>
-          <a:bodyPr wrap="square" lIns="0" tIns="0" rIns="0" bIns="0" anchor="t">
-            <a:spAutoFit/>
-          </a:bodyPr>
-          <a:lstStyle/>
-          <a:p>
-            <a:pPr algn="l"/>
-            <a:r>
-              <a:rPr sz="2100" b="0" i="0" u="none">
-                <a:solidFill>
-                  <a:srgbClr val="0284C7"/>
-                </a:solidFill>
-                <a:latin typeface="Montserrat SemiBold"/>
-              </a:rPr>
-              <a:t>Ethnicity Compression</a:t>
-            </a:r>
-          </a:p>
-        </p:txBody>
-      </p:sp>
-      <p:sp>
-        <p:nvSpPr>
-          <p:cNvPr id="8" name="TextBox 7"/>
-          <p:cNvSpPr txBox="1"/>
-          <p:nvPr/>
-        </p:nvSpPr>
-        <p:spPr>
-          <a:xfrm>
-            <a:off x="6724650" y="3343275"/>
-            <a:ext cx="4505325" cy="1524000"/>
-          </a:xfrm>
-          <a:prstGeom prst="rect">
-            <a:avLst/>
-          </a:prstGeom>
-          <a:noFill/>
-        </p:spPr>
-        <p:txBody>
-          <a:bodyPr wrap="square" lIns="0" tIns="0" rIns="0" bIns="0" anchor="t">
-            <a:spAutoFit/>
-          </a:bodyPr>
-          <a:lstStyle/>
+              <a:t>Religion Normalization: </a:t>
+            </a:r>
+            <a:r>
+              <a:rPr b="0" i="0" u="none" dirty="0">
+                <a:solidFill>
+                  <a:srgbClr val="334155"/>
+                </a:solidFill>
+                <a:latin typeface="Open Sans"/>
+              </a:rPr>
+              <a:t>The dataset contained multiple fragmented religious affiliations. We utilized </a:t>
+            </a:r>
+            <a:r>
+              <a:rPr b="0" i="0" u="none" dirty="0" err="1">
+                <a:solidFill>
+                  <a:srgbClr val="334155"/>
+                </a:solidFill>
+                <a:latin typeface="Open Sans"/>
+              </a:rPr>
+              <a:t>RegEx</a:t>
+            </a:r>
+            <a:r>
+              <a:rPr b="0" i="0" u="none" dirty="0">
+                <a:solidFill>
+                  <a:srgbClr val="334155"/>
+                </a:solidFill>
+                <a:latin typeface="Open Sans"/>
+              </a:rPr>
+              <a:t> patterns to group these responses into a binary 'RELIGIOUS' vs. 'NOT RELIGIOUS' flag</a:t>
+            </a:r>
+            <a:r>
+              <a:rPr lang="en-US" dirty="0">
+                <a:solidFill>
+                  <a:srgbClr val="334155"/>
+                </a:solidFill>
+                <a:latin typeface="Open Sans"/>
+              </a:rPr>
+              <a:t>.</a:t>
+            </a:r>
+          </a:p>
           <a:p>
             <a:pPr algn="l">
               <a:lnSpc>
                 <a:spcPts val="2400"/>
               </a:lnSpc>
             </a:pPr>
-            <a:r>
-              <a:rPr sz="1500" b="0" i="0" u="none">
+            <a:endParaRPr lang="en-US" b="0" i="0" u="none" dirty="0">
+              <a:solidFill>
+                <a:srgbClr val="334155"/>
+              </a:solidFill>
+              <a:latin typeface="Open Sans"/>
+            </a:endParaRPr>
+          </a:p>
+          <a:p>
+            <a:pPr>
+              <a:lnSpc>
+                <a:spcPts val="2400"/>
+              </a:lnSpc>
+            </a:pPr>
+            <a:r>
+              <a:rPr lang="en-US" dirty="0">
                 <a:solidFill>
                   <a:srgbClr val="334155"/>
                 </a:solidFill>
                 <a:latin typeface="Open Sans"/>
               </a:rPr>
-              <a:t>To prevent extreme high-cardinality in categorical features, we condensed the ethnicity data down to the top 5 most frequent groups (WHITE, ASIAN, BLACK, HISPANIC) and lumped the remainder into 'OTHER/UNKNOWN'.</a:t>
-            </a:r>
+              <a:t>Ethnicity Compression: To prevent extreme high-cardinality in categorical features, we condensed the ethnicity data down to the top 5 most frequent groups (White, Asian, Black, Hispanic) and lumped the remainder into 'OTHER/UNKNOWN'.</a:t>
+            </a:r>
+          </a:p>
+          <a:p>
+            <a:pPr algn="l">
+              <a:lnSpc>
+                <a:spcPts val="2400"/>
+              </a:lnSpc>
+            </a:pPr>
+            <a:endParaRPr b="0" i="0" u="none" dirty="0">
+              <a:solidFill>
+                <a:srgbClr val="334155"/>
+              </a:solidFill>
+              <a:latin typeface="Open Sans"/>
+            </a:endParaRPr>
           </a:p>
         </p:txBody>
       </p:sp>
@@ -6380,6 +6807,36 @@
           </a:p>
         </p:txBody>
       </p:sp>
+      <p:pic>
+        <p:nvPicPr>
+          <p:cNvPr id="12" name="Picture 11">
+            <a:extLst>
+              <a:ext uri="{FF2B5EF4-FFF2-40B4-BE49-F238E27FC236}">
+                <a16:creationId xmlns:a16="http://schemas.microsoft.com/office/drawing/2014/main" id="{B13E4AA7-F69B-893A-06B2-E9777935812A}"/>
+              </a:ext>
+            </a:extLst>
+          </p:cNvPr>
+          <p:cNvPicPr>
+            <a:picLocks noChangeAspect="1"/>
+          </p:cNvPicPr>
+          <p:nvPr/>
+        </p:nvPicPr>
+        <p:blipFill>
+          <a:blip r:embed="rId2"/>
+          <a:stretch>
+            <a:fillRect/>
+          </a:stretch>
+        </p:blipFill>
+        <p:spPr>
+          <a:xfrm>
+            <a:off x="7162178" y="1566363"/>
+            <a:ext cx="4458322" cy="4420217"/>
+          </a:xfrm>
+          <a:prstGeom prst="rect">
+            <a:avLst/>
+          </a:prstGeom>
+        </p:spPr>
+      </p:pic>
     </p:spTree>
   </p:cSld>
   <p:clrMapOvr>
@@ -8068,4 +8525,10 @@
   </a:objectDefaults>
   <a:extraClrSchemeLst/>
 </a:theme>
+</file>
+
+<file path=docMetadata/LabelInfo.xml><?xml version="1.0" encoding="utf-8"?>
+<clbl:labelList xmlns:clbl="http://schemas.microsoft.com/office/2020/mipLabelMetadata">
+  <clbl:label id="{ae87f501-3025-4ed4-90da-080ba37c525d}" enabled="0" method="" siteId="{ae87f501-3025-4ed4-90da-080ba37c525d}" removed="1"/>
+</clbl:labelList>
 </file>
</xml_diff>